<commit_message>
update talk slides and README
</commit_message>
<xml_diff>
--- a/talk/CLEF 2024 talk Luis Kolb.pptx
+++ b/talk/CLEF 2024 talk Luis Kolb.pptx
@@ -2,35 +2,35 @@
 <file path=ppt/presentation.xml><?xml version="1.0" encoding="utf-8"?>
 <p:presentation xmlns:a="http://schemas.openxmlformats.org/drawingml/2006/main" xmlns:r="http://schemas.openxmlformats.org/officeDocument/2006/relationships" xmlns:p="http://schemas.openxmlformats.org/presentationml/2006/main" saveSubsetFonts="1">
   <p:sldMasterIdLst>
-    <p:sldMasterId id="2147483762" r:id="rId1"/>
+    <p:sldMasterId id="2147483762" r:id="rId4"/>
   </p:sldMasterIdLst>
   <p:notesMasterIdLst>
-    <p:notesMasterId r:id="rId25"/>
+    <p:notesMasterId r:id="rId28"/>
   </p:notesMasterIdLst>
   <p:sldIdLst>
-    <p:sldId id="256" r:id="rId2"/>
-    <p:sldId id="257" r:id="rId3"/>
-    <p:sldId id="274" r:id="rId4"/>
-    <p:sldId id="277" r:id="rId5"/>
-    <p:sldId id="259" r:id="rId6"/>
-    <p:sldId id="278" r:id="rId7"/>
-    <p:sldId id="276" r:id="rId8"/>
-    <p:sldId id="260" r:id="rId9"/>
-    <p:sldId id="275" r:id="rId10"/>
-    <p:sldId id="261" r:id="rId11"/>
-    <p:sldId id="283" r:id="rId12"/>
-    <p:sldId id="266" r:id="rId13"/>
-    <p:sldId id="270" r:id="rId14"/>
-    <p:sldId id="271" r:id="rId15"/>
-    <p:sldId id="267" r:id="rId16"/>
-    <p:sldId id="268" r:id="rId17"/>
-    <p:sldId id="281" r:id="rId18"/>
-    <p:sldId id="269" r:id="rId19"/>
-    <p:sldId id="280" r:id="rId20"/>
-    <p:sldId id="272" r:id="rId21"/>
-    <p:sldId id="282" r:id="rId22"/>
-    <p:sldId id="265" r:id="rId23"/>
-    <p:sldId id="273" r:id="rId24"/>
+    <p:sldId id="256" r:id="rId5"/>
+    <p:sldId id="257" r:id="rId6"/>
+    <p:sldId id="274" r:id="rId7"/>
+    <p:sldId id="277" r:id="rId8"/>
+    <p:sldId id="259" r:id="rId9"/>
+    <p:sldId id="278" r:id="rId10"/>
+    <p:sldId id="276" r:id="rId11"/>
+    <p:sldId id="260" r:id="rId12"/>
+    <p:sldId id="275" r:id="rId13"/>
+    <p:sldId id="261" r:id="rId14"/>
+    <p:sldId id="283" r:id="rId15"/>
+    <p:sldId id="266" r:id="rId16"/>
+    <p:sldId id="270" r:id="rId17"/>
+    <p:sldId id="271" r:id="rId18"/>
+    <p:sldId id="267" r:id="rId19"/>
+    <p:sldId id="268" r:id="rId20"/>
+    <p:sldId id="281" r:id="rId21"/>
+    <p:sldId id="269" r:id="rId22"/>
+    <p:sldId id="280" r:id="rId23"/>
+    <p:sldId id="272" r:id="rId24"/>
+    <p:sldId id="282" r:id="rId25"/>
+    <p:sldId id="265" r:id="rId26"/>
+    <p:sldId id="273" r:id="rId27"/>
   </p:sldIdLst>
   <p:sldSz cx="12192000" cy="6858000"/>
   <p:notesSz cx="6858000" cy="9144000"/>
@@ -143,7 +143,7 @@
 <file path=ppt/revisionInfo.xml><?xml version="1.0" encoding="utf-8"?>
 <p1510:revInfo xmlns:a="http://schemas.openxmlformats.org/drawingml/2006/main" xmlns:r="http://schemas.openxmlformats.org/officeDocument/2006/relationships" xmlns:p1510="http://schemas.microsoft.com/office/powerpoint/2015/10/main">
   <p1510:revLst>
-    <p1510:client id="{588165A0-8051-412E-BC9D-487F86FBB3BA}" v="78" dt="2024-09-04T16:48:18.063"/>
+    <p1510:client id="{4A6D8CD1-6793-492C-94F0-704C1E5CA1CF}" v="98" dt="2024-09-10T15:51:22.319"/>
   </p1510:revLst>
 </p1510:revInfo>
 </file>
@@ -230,7 +230,7 @@
           <a:p>
             <a:fld id="{15BD401B-D4A8-4898-8F84-9494CF2831B3}" type="datetimeFigureOut">
               <a:rPr lang="en-AT" smtClean="0"/>
-              <a:t>4 Sep 2024</a:t>
+              <a:t>09/10/2024</a:t>
             </a:fld>
             <a:endParaRPr lang="en-AT"/>
           </a:p>
@@ -542,7 +542,7 @@
           <a:bodyPr/>
           <a:lstStyle/>
           <a:p>
-            <a:endParaRPr lang="en-AT" dirty="0"/>
+            <a:endParaRPr lang="en-AT"/>
           </a:p>
         </p:txBody>
       </p:sp>
@@ -565,7 +565,7 @@
               <a:rPr lang="en-AT" smtClean="0"/>
               <a:t>1</a:t>
             </a:fld>
-            <a:endParaRPr lang="en-AT" dirty="0"/>
+            <a:endParaRPr lang="en-AT"/>
           </a:p>
         </p:txBody>
       </p:sp>
@@ -573,6 +573,770 @@
     <p:extLst>
       <p:ext uri="{BB962C8B-B14F-4D97-AF65-F5344CB8AC3E}">
         <p14:creationId xmlns:p14="http://schemas.microsoft.com/office/powerpoint/2010/main" val="1706637639"/>
+      </p:ext>
+    </p:extLst>
+  </p:cSld>
+  <p:clrMapOvr>
+    <a:masterClrMapping/>
+  </p:clrMapOvr>
+</p:notes>
+</file>
+
+<file path=ppt/notesSlides/notesSlide10.xml><?xml version="1.0" encoding="utf-8"?>
+<p:notes xmlns:a="http://schemas.openxmlformats.org/drawingml/2006/main" xmlns:r="http://schemas.openxmlformats.org/officeDocument/2006/relationships" xmlns:p="http://schemas.openxmlformats.org/presentationml/2006/main">
+  <p:cSld>
+    <p:spTree>
+      <p:nvGrpSpPr>
+        <p:cNvPr id="1" name=""/>
+        <p:cNvGrpSpPr/>
+        <p:nvPr/>
+      </p:nvGrpSpPr>
+      <p:grpSpPr>
+        <a:xfrm>
+          <a:off x="0" y="0"/>
+          <a:ext cx="0" cy="0"/>
+          <a:chOff x="0" y="0"/>
+          <a:chExt cx="0" cy="0"/>
+        </a:xfrm>
+      </p:grpSpPr>
+      <p:sp>
+        <p:nvSpPr>
+          <p:cNvPr id="2" name="Folienbildplatzhalter 1"/>
+          <p:cNvSpPr>
+            <a:spLocks noGrp="1" noRot="1" noChangeAspect="1"/>
+          </p:cNvSpPr>
+          <p:nvPr>
+            <p:ph type="sldImg"/>
+          </p:nvPr>
+        </p:nvSpPr>
+        <p:spPr/>
+      </p:sp>
+      <p:sp>
+        <p:nvSpPr>
+          <p:cNvPr id="3" name="Notizenplatzhalter 2"/>
+          <p:cNvSpPr>
+            <a:spLocks noGrp="1"/>
+          </p:cNvSpPr>
+          <p:nvPr>
+            <p:ph type="body" idx="1"/>
+          </p:nvPr>
+        </p:nvSpPr>
+        <p:spPr/>
+        <p:txBody>
+          <a:bodyPr/>
+          <a:lstStyle/>
+          <a:p>
+            <a:r>
+              <a:rPr lang="de-DE" dirty="0"/>
+              <a:t>…but </a:t>
+            </a:r>
+            <a:r>
+              <a:rPr lang="de-DE" dirty="0" err="1"/>
+              <a:t>our</a:t>
+            </a:r>
+            <a:r>
+              <a:rPr lang="de-DE" dirty="0"/>
+              <a:t> </a:t>
+            </a:r>
+            <a:r>
+              <a:rPr lang="de-DE" dirty="0" err="1"/>
+              <a:t>Verification</a:t>
+            </a:r>
+            <a:r>
+              <a:rPr lang="de-DE" dirty="0"/>
+              <a:t> </a:t>
+            </a:r>
+            <a:r>
+              <a:rPr lang="de-DE" dirty="0" err="1"/>
+              <a:t>performance</a:t>
+            </a:r>
+            <a:r>
+              <a:rPr lang="de-DE" dirty="0"/>
+              <a:t> was </a:t>
+            </a:r>
+            <a:r>
+              <a:rPr lang="de-DE" dirty="0" err="1"/>
+              <a:t>great</a:t>
+            </a:r>
+            <a:r>
+              <a:rPr lang="de-DE" dirty="0"/>
+              <a:t>. </a:t>
+            </a:r>
+            <a:r>
+              <a:rPr lang="de-DE" dirty="0" err="1"/>
+              <a:t>We‘ll</a:t>
+            </a:r>
+            <a:r>
+              <a:rPr lang="de-DE" dirty="0"/>
+              <a:t> </a:t>
+            </a:r>
+            <a:r>
+              <a:rPr lang="de-DE" dirty="0" err="1"/>
+              <a:t>get</a:t>
+            </a:r>
+            <a:r>
+              <a:rPr lang="de-DE" dirty="0"/>
+              <a:t> </a:t>
+            </a:r>
+            <a:r>
+              <a:rPr lang="de-DE" dirty="0" err="1"/>
+              <a:t>to</a:t>
+            </a:r>
+            <a:r>
+              <a:rPr lang="de-DE" dirty="0"/>
+              <a:t> </a:t>
+            </a:r>
+            <a:r>
+              <a:rPr lang="de-DE" dirty="0" err="1"/>
+              <a:t>that</a:t>
+            </a:r>
+            <a:r>
+              <a:rPr lang="de-DE" dirty="0"/>
+              <a:t> in a </a:t>
+            </a:r>
+            <a:r>
+              <a:rPr lang="de-DE" dirty="0" err="1"/>
+              <a:t>minute</a:t>
+            </a:r>
+            <a:r>
+              <a:rPr lang="de-DE" dirty="0"/>
+              <a:t>. (Retrieval </a:t>
+            </a:r>
+            <a:r>
+              <a:rPr lang="de-DE" dirty="0" err="1"/>
+              <a:t>only</a:t>
+            </a:r>
+            <a:r>
+              <a:rPr lang="de-DE" dirty="0"/>
+              <a:t> </a:t>
+            </a:r>
+            <a:r>
+              <a:rPr lang="de-DE" dirty="0" err="1"/>
+              <a:t>needs</a:t>
+            </a:r>
+            <a:r>
+              <a:rPr lang="de-DE" dirty="0"/>
+              <a:t> </a:t>
+            </a:r>
+            <a:r>
+              <a:rPr lang="de-DE" dirty="0" err="1"/>
+              <a:t>to</a:t>
+            </a:r>
+            <a:r>
+              <a:rPr lang="de-DE" dirty="0"/>
+              <a:t> find </a:t>
+            </a:r>
+            <a:r>
+              <a:rPr lang="de-DE" dirty="0" err="1"/>
+              <a:t>the</a:t>
+            </a:r>
+            <a:r>
+              <a:rPr lang="de-DE" dirty="0"/>
+              <a:t> </a:t>
+            </a:r>
+            <a:r>
+              <a:rPr lang="de-DE" dirty="0" err="1"/>
+              <a:t>correct</a:t>
+            </a:r>
+            <a:r>
+              <a:rPr lang="de-DE" dirty="0"/>
+              <a:t> </a:t>
+            </a:r>
+            <a:r>
+              <a:rPr lang="de-DE" dirty="0" err="1"/>
+              <a:t>evidence</a:t>
+            </a:r>
+            <a:r>
+              <a:rPr lang="de-DE" dirty="0"/>
+              <a:t> </a:t>
+            </a:r>
+            <a:r>
+              <a:rPr lang="de-DE" dirty="0" err="1"/>
+              <a:t>somewhere</a:t>
+            </a:r>
+            <a:r>
+              <a:rPr lang="de-DE" dirty="0"/>
+              <a:t>, </a:t>
+            </a:r>
+            <a:r>
+              <a:rPr lang="de-DE" dirty="0" err="1"/>
+              <a:t>rest</a:t>
+            </a:r>
+            <a:r>
+              <a:rPr lang="de-DE" dirty="0"/>
+              <a:t> </a:t>
+            </a:r>
+            <a:r>
+              <a:rPr lang="de-DE" dirty="0" err="1"/>
+              <a:t>of</a:t>
+            </a:r>
+            <a:r>
+              <a:rPr lang="de-DE" dirty="0"/>
+              <a:t> </a:t>
+            </a:r>
+            <a:r>
+              <a:rPr lang="de-DE" dirty="0" err="1"/>
+              <a:t>the</a:t>
+            </a:r>
+            <a:r>
+              <a:rPr lang="de-DE" dirty="0"/>
+              <a:t> </a:t>
+            </a:r>
+            <a:r>
+              <a:rPr lang="de-DE" dirty="0" err="1"/>
+              <a:t>setup</a:t>
+            </a:r>
+            <a:r>
+              <a:rPr lang="de-DE" dirty="0"/>
+              <a:t> </a:t>
+            </a:r>
+            <a:r>
+              <a:rPr lang="de-DE" dirty="0" err="1"/>
+              <a:t>is</a:t>
+            </a:r>
+            <a:r>
+              <a:rPr lang="de-DE" dirty="0"/>
+              <a:t> </a:t>
+            </a:r>
+            <a:r>
+              <a:rPr lang="de-DE" dirty="0" err="1"/>
+              <a:t>good</a:t>
+            </a:r>
+            <a:r>
+              <a:rPr lang="de-DE" dirty="0"/>
+              <a:t> </a:t>
+            </a:r>
+            <a:r>
+              <a:rPr lang="de-DE" dirty="0" err="1"/>
+              <a:t>enough</a:t>
+            </a:r>
+            <a:r>
+              <a:rPr lang="de-DE" dirty="0"/>
+              <a:t>, </a:t>
+            </a:r>
+            <a:r>
+              <a:rPr lang="de-DE" dirty="0" err="1"/>
+              <a:t>ranking</a:t>
+            </a:r>
+            <a:r>
+              <a:rPr lang="de-DE" dirty="0"/>
+              <a:t> </a:t>
+            </a:r>
+            <a:r>
+              <a:rPr lang="de-DE" dirty="0" err="1"/>
+              <a:t>doesn‘t</a:t>
+            </a:r>
+            <a:r>
+              <a:rPr lang="de-DE" dirty="0"/>
+              <a:t> matter)</a:t>
+            </a:r>
+            <a:endParaRPr lang="de-AT" dirty="0"/>
+          </a:p>
+        </p:txBody>
+      </p:sp>
+      <p:sp>
+        <p:nvSpPr>
+          <p:cNvPr id="4" name="Foliennummernplatzhalter 3"/>
+          <p:cNvSpPr>
+            <a:spLocks noGrp="1"/>
+          </p:cNvSpPr>
+          <p:nvPr>
+            <p:ph type="sldNum" sz="quarter" idx="5"/>
+          </p:nvPr>
+        </p:nvSpPr>
+        <p:spPr/>
+        <p:txBody>
+          <a:bodyPr/>
+          <a:lstStyle/>
+          <a:p>
+            <a:fld id="{4B7EC79C-4F4E-40A6-BD42-D4E6BA83A575}" type="slidenum">
+              <a:rPr lang="en-AT" smtClean="0"/>
+              <a:t>14</a:t>
+            </a:fld>
+            <a:endParaRPr lang="en-AT"/>
+          </a:p>
+        </p:txBody>
+      </p:sp>
+    </p:spTree>
+    <p:extLst>
+      <p:ext uri="{BB962C8B-B14F-4D97-AF65-F5344CB8AC3E}">
+        <p14:creationId xmlns:p14="http://schemas.microsoft.com/office/powerpoint/2010/main" val="4444187"/>
+      </p:ext>
+    </p:extLst>
+  </p:cSld>
+  <p:clrMapOvr>
+    <a:masterClrMapping/>
+  </p:clrMapOvr>
+</p:notes>
+</file>
+
+<file path=ppt/notesSlides/notesSlide11.xml><?xml version="1.0" encoding="utf-8"?>
+<p:notes xmlns:a="http://schemas.openxmlformats.org/drawingml/2006/main" xmlns:r="http://schemas.openxmlformats.org/officeDocument/2006/relationships" xmlns:p="http://schemas.openxmlformats.org/presentationml/2006/main">
+  <p:cSld>
+    <p:spTree>
+      <p:nvGrpSpPr>
+        <p:cNvPr id="1" name=""/>
+        <p:cNvGrpSpPr/>
+        <p:nvPr/>
+      </p:nvGrpSpPr>
+      <p:grpSpPr>
+        <a:xfrm>
+          <a:off x="0" y="0"/>
+          <a:ext cx="0" cy="0"/>
+          <a:chOff x="0" y="0"/>
+          <a:chExt cx="0" cy="0"/>
+        </a:xfrm>
+      </p:grpSpPr>
+      <p:sp>
+        <p:nvSpPr>
+          <p:cNvPr id="2" name="Folienbildplatzhalter 1"/>
+          <p:cNvSpPr>
+            <a:spLocks noGrp="1" noRot="1" noChangeAspect="1"/>
+          </p:cNvSpPr>
+          <p:nvPr>
+            <p:ph type="sldImg"/>
+          </p:nvPr>
+        </p:nvSpPr>
+        <p:spPr/>
+      </p:sp>
+      <p:sp>
+        <p:nvSpPr>
+          <p:cNvPr id="3" name="Notizenplatzhalter 2"/>
+          <p:cNvSpPr>
+            <a:spLocks noGrp="1"/>
+          </p:cNvSpPr>
+          <p:nvPr>
+            <p:ph type="body" idx="1"/>
+          </p:nvPr>
+        </p:nvSpPr>
+        <p:spPr/>
+        <p:txBody>
+          <a:bodyPr/>
+          <a:lstStyle/>
+          <a:p>
+            <a:r>
+              <a:rPr lang="de-DE" dirty="0"/>
+              <a:t>(Retrieval </a:t>
+            </a:r>
+            <a:r>
+              <a:rPr lang="de-DE" dirty="0" err="1"/>
+              <a:t>only</a:t>
+            </a:r>
+            <a:r>
+              <a:rPr lang="de-DE" dirty="0"/>
+              <a:t> </a:t>
+            </a:r>
+            <a:r>
+              <a:rPr lang="de-DE" dirty="0" err="1"/>
+              <a:t>needs</a:t>
+            </a:r>
+            <a:r>
+              <a:rPr lang="de-DE" dirty="0"/>
+              <a:t> </a:t>
+            </a:r>
+            <a:r>
+              <a:rPr lang="de-DE" dirty="0" err="1"/>
+              <a:t>to</a:t>
+            </a:r>
+            <a:r>
+              <a:rPr lang="de-DE" dirty="0"/>
+              <a:t> find </a:t>
+            </a:r>
+            <a:r>
+              <a:rPr lang="de-DE" dirty="0" err="1"/>
+              <a:t>the</a:t>
+            </a:r>
+            <a:r>
+              <a:rPr lang="de-DE" dirty="0"/>
+              <a:t> </a:t>
+            </a:r>
+            <a:r>
+              <a:rPr lang="de-DE" dirty="0" err="1"/>
+              <a:t>correct</a:t>
+            </a:r>
+            <a:r>
+              <a:rPr lang="de-DE" dirty="0"/>
+              <a:t> </a:t>
+            </a:r>
+            <a:r>
+              <a:rPr lang="de-DE" dirty="0" err="1"/>
+              <a:t>evidence</a:t>
+            </a:r>
+            <a:r>
+              <a:rPr lang="de-DE" dirty="0"/>
+              <a:t> </a:t>
+            </a:r>
+            <a:r>
+              <a:rPr lang="de-DE" dirty="0" err="1"/>
+              <a:t>somewhere</a:t>
+            </a:r>
+            <a:r>
+              <a:rPr lang="de-DE" dirty="0"/>
+              <a:t>, </a:t>
+            </a:r>
+            <a:r>
+              <a:rPr lang="de-DE" dirty="0" err="1"/>
+              <a:t>rest</a:t>
+            </a:r>
+            <a:r>
+              <a:rPr lang="de-DE" dirty="0"/>
+              <a:t> </a:t>
+            </a:r>
+            <a:r>
+              <a:rPr lang="de-DE" dirty="0" err="1"/>
+              <a:t>of</a:t>
+            </a:r>
+            <a:r>
+              <a:rPr lang="de-DE" dirty="0"/>
+              <a:t> </a:t>
+            </a:r>
+            <a:r>
+              <a:rPr lang="de-DE" dirty="0" err="1"/>
+              <a:t>the</a:t>
+            </a:r>
+            <a:r>
+              <a:rPr lang="de-DE" dirty="0"/>
+              <a:t> </a:t>
+            </a:r>
+            <a:r>
+              <a:rPr lang="de-DE" dirty="0" err="1"/>
+              <a:t>setup</a:t>
+            </a:r>
+            <a:r>
+              <a:rPr lang="de-DE" dirty="0"/>
+              <a:t> </a:t>
+            </a:r>
+            <a:r>
+              <a:rPr lang="de-DE" dirty="0" err="1"/>
+              <a:t>is</a:t>
+            </a:r>
+            <a:r>
+              <a:rPr lang="de-DE" dirty="0"/>
+              <a:t> </a:t>
+            </a:r>
+            <a:r>
+              <a:rPr lang="de-DE" dirty="0" err="1"/>
+              <a:t>good</a:t>
+            </a:r>
+            <a:r>
+              <a:rPr lang="de-DE" dirty="0"/>
+              <a:t> </a:t>
+            </a:r>
+            <a:r>
+              <a:rPr lang="de-DE" dirty="0" err="1"/>
+              <a:t>enough</a:t>
+            </a:r>
+            <a:r>
+              <a:rPr lang="de-DE" dirty="0"/>
+              <a:t>, </a:t>
+            </a:r>
+            <a:r>
+              <a:rPr lang="de-DE" dirty="0" err="1"/>
+              <a:t>ranking</a:t>
+            </a:r>
+            <a:r>
+              <a:rPr lang="de-DE" dirty="0"/>
+              <a:t> </a:t>
+            </a:r>
+            <a:r>
+              <a:rPr lang="de-DE" dirty="0" err="1"/>
+              <a:t>doesn‘t</a:t>
+            </a:r>
+            <a:r>
+              <a:rPr lang="de-DE" dirty="0"/>
+              <a:t> matter)</a:t>
+            </a:r>
+            <a:endParaRPr lang="de-AT" dirty="0"/>
+          </a:p>
+        </p:txBody>
+      </p:sp>
+      <p:sp>
+        <p:nvSpPr>
+          <p:cNvPr id="4" name="Foliennummernplatzhalter 3"/>
+          <p:cNvSpPr>
+            <a:spLocks noGrp="1"/>
+          </p:cNvSpPr>
+          <p:nvPr>
+            <p:ph type="sldNum" sz="quarter" idx="5"/>
+          </p:nvPr>
+        </p:nvSpPr>
+        <p:spPr/>
+        <p:txBody>
+          <a:bodyPr/>
+          <a:lstStyle/>
+          <a:p>
+            <a:fld id="{4B7EC79C-4F4E-40A6-BD42-D4E6BA83A575}" type="slidenum">
+              <a:rPr lang="en-AT" smtClean="0"/>
+              <a:t>16</a:t>
+            </a:fld>
+            <a:endParaRPr lang="en-AT"/>
+          </a:p>
+        </p:txBody>
+      </p:sp>
+    </p:spTree>
+    <p:extLst>
+      <p:ext uri="{BB962C8B-B14F-4D97-AF65-F5344CB8AC3E}">
+        <p14:creationId xmlns:p14="http://schemas.microsoft.com/office/powerpoint/2010/main" val="2450638522"/>
+      </p:ext>
+    </p:extLst>
+  </p:cSld>
+  <p:clrMapOvr>
+    <a:masterClrMapping/>
+  </p:clrMapOvr>
+</p:notes>
+</file>
+
+<file path=ppt/notesSlides/notesSlide12.xml><?xml version="1.0" encoding="utf-8"?>
+<p:notes xmlns:a="http://schemas.openxmlformats.org/drawingml/2006/main" xmlns:r="http://schemas.openxmlformats.org/officeDocument/2006/relationships" xmlns:p="http://schemas.openxmlformats.org/presentationml/2006/main">
+  <p:cSld>
+    <p:spTree>
+      <p:nvGrpSpPr>
+        <p:cNvPr id="1" name=""/>
+        <p:cNvGrpSpPr/>
+        <p:nvPr/>
+      </p:nvGrpSpPr>
+      <p:grpSpPr>
+        <a:xfrm>
+          <a:off x="0" y="0"/>
+          <a:ext cx="0" cy="0"/>
+          <a:chOff x="0" y="0"/>
+          <a:chExt cx="0" cy="0"/>
+        </a:xfrm>
+      </p:grpSpPr>
+      <p:sp>
+        <p:nvSpPr>
+          <p:cNvPr id="2" name="Folienbildplatzhalter 1"/>
+          <p:cNvSpPr>
+            <a:spLocks noGrp="1" noRot="1" noChangeAspect="1"/>
+          </p:cNvSpPr>
+          <p:nvPr>
+            <p:ph type="sldImg"/>
+          </p:nvPr>
+        </p:nvSpPr>
+        <p:spPr/>
+      </p:sp>
+      <p:sp>
+        <p:nvSpPr>
+          <p:cNvPr id="3" name="Notizenplatzhalter 2"/>
+          <p:cNvSpPr>
+            <a:spLocks noGrp="1"/>
+          </p:cNvSpPr>
+          <p:nvPr>
+            <p:ph type="body" idx="1"/>
+          </p:nvPr>
+        </p:nvSpPr>
+        <p:spPr/>
+        <p:txBody>
+          <a:bodyPr/>
+          <a:lstStyle/>
+          <a:p>
+            <a:endParaRPr lang="de-AT" dirty="0"/>
+          </a:p>
+        </p:txBody>
+      </p:sp>
+      <p:sp>
+        <p:nvSpPr>
+          <p:cNvPr id="4" name="Foliennummernplatzhalter 3"/>
+          <p:cNvSpPr>
+            <a:spLocks noGrp="1"/>
+          </p:cNvSpPr>
+          <p:nvPr>
+            <p:ph type="sldNum" sz="quarter" idx="5"/>
+          </p:nvPr>
+        </p:nvSpPr>
+        <p:spPr/>
+        <p:txBody>
+          <a:bodyPr/>
+          <a:lstStyle/>
+          <a:p>
+            <a:fld id="{4B7EC79C-4F4E-40A6-BD42-D4E6BA83A575}" type="slidenum">
+              <a:rPr lang="en-AT" smtClean="0"/>
+              <a:t>17</a:t>
+            </a:fld>
+            <a:endParaRPr lang="en-AT"/>
+          </a:p>
+        </p:txBody>
+      </p:sp>
+    </p:spTree>
+    <p:extLst>
+      <p:ext uri="{BB962C8B-B14F-4D97-AF65-F5344CB8AC3E}">
+        <p14:creationId xmlns:p14="http://schemas.microsoft.com/office/powerpoint/2010/main" val="2555009643"/>
+      </p:ext>
+    </p:extLst>
+  </p:cSld>
+  <p:clrMapOvr>
+    <a:masterClrMapping/>
+  </p:clrMapOvr>
+</p:notes>
+</file>
+
+<file path=ppt/notesSlides/notesSlide13.xml><?xml version="1.0" encoding="utf-8"?>
+<p:notes xmlns:a="http://schemas.openxmlformats.org/drawingml/2006/main" xmlns:r="http://schemas.openxmlformats.org/officeDocument/2006/relationships" xmlns:p="http://schemas.openxmlformats.org/presentationml/2006/main">
+  <p:cSld>
+    <p:spTree>
+      <p:nvGrpSpPr>
+        <p:cNvPr id="1" name=""/>
+        <p:cNvGrpSpPr/>
+        <p:nvPr/>
+      </p:nvGrpSpPr>
+      <p:grpSpPr>
+        <a:xfrm>
+          <a:off x="0" y="0"/>
+          <a:ext cx="0" cy="0"/>
+          <a:chOff x="0" y="0"/>
+          <a:chExt cx="0" cy="0"/>
+        </a:xfrm>
+      </p:grpSpPr>
+      <p:sp>
+        <p:nvSpPr>
+          <p:cNvPr id="2" name="Folienbildplatzhalter 1"/>
+          <p:cNvSpPr>
+            <a:spLocks noGrp="1" noRot="1" noChangeAspect="1"/>
+          </p:cNvSpPr>
+          <p:nvPr>
+            <p:ph type="sldImg"/>
+          </p:nvPr>
+        </p:nvSpPr>
+        <p:spPr/>
+      </p:sp>
+      <p:sp>
+        <p:nvSpPr>
+          <p:cNvPr id="3" name="Notizenplatzhalter 2"/>
+          <p:cNvSpPr>
+            <a:spLocks noGrp="1"/>
+          </p:cNvSpPr>
+          <p:nvPr>
+            <p:ph type="body" idx="1"/>
+          </p:nvPr>
+        </p:nvSpPr>
+        <p:spPr/>
+        <p:txBody>
+          <a:bodyPr/>
+          <a:lstStyle/>
+          <a:p>
+            <a:r>
+              <a:rPr lang="en-US"/>
+              <a:t>I’ve participated in this shared task as part of my Master’s Thesis, as such I’ve made some more findings since…</a:t>
+            </a:r>
+            <a:endParaRPr lang="en-AT"/>
+          </a:p>
+        </p:txBody>
+      </p:sp>
+      <p:sp>
+        <p:nvSpPr>
+          <p:cNvPr id="4" name="Foliennummernplatzhalter 3"/>
+          <p:cNvSpPr>
+            <a:spLocks noGrp="1"/>
+          </p:cNvSpPr>
+          <p:nvPr>
+            <p:ph type="sldNum" sz="quarter" idx="5"/>
+          </p:nvPr>
+        </p:nvSpPr>
+        <p:spPr/>
+        <p:txBody>
+          <a:bodyPr/>
+          <a:lstStyle/>
+          <a:p>
+            <a:fld id="{4B7EC79C-4F4E-40A6-BD42-D4E6BA83A575}" type="slidenum">
+              <a:rPr lang="en-AT" smtClean="0"/>
+              <a:t>18</a:t>
+            </a:fld>
+            <a:endParaRPr lang="en-AT"/>
+          </a:p>
+        </p:txBody>
+      </p:sp>
+    </p:spTree>
+    <p:extLst>
+      <p:ext uri="{BB962C8B-B14F-4D97-AF65-F5344CB8AC3E}">
+        <p14:creationId xmlns:p14="http://schemas.microsoft.com/office/powerpoint/2010/main" val="3232905122"/>
+      </p:ext>
+    </p:extLst>
+  </p:cSld>
+  <p:clrMapOvr>
+    <a:masterClrMapping/>
+  </p:clrMapOvr>
+</p:notes>
+</file>
+
+<file path=ppt/notesSlides/notesSlide14.xml><?xml version="1.0" encoding="utf-8"?>
+<p:notes xmlns:a="http://schemas.openxmlformats.org/drawingml/2006/main" xmlns:r="http://schemas.openxmlformats.org/officeDocument/2006/relationships" xmlns:p="http://schemas.openxmlformats.org/presentationml/2006/main">
+  <p:cSld>
+    <p:spTree>
+      <p:nvGrpSpPr>
+        <p:cNvPr id="1" name=""/>
+        <p:cNvGrpSpPr/>
+        <p:nvPr/>
+      </p:nvGrpSpPr>
+      <p:grpSpPr>
+        <a:xfrm>
+          <a:off x="0" y="0"/>
+          <a:ext cx="0" cy="0"/>
+          <a:chOff x="0" y="0"/>
+          <a:chExt cx="0" cy="0"/>
+        </a:xfrm>
+      </p:grpSpPr>
+      <p:sp>
+        <p:nvSpPr>
+          <p:cNvPr id="2" name="Folienbildplatzhalter 1"/>
+          <p:cNvSpPr>
+            <a:spLocks noGrp="1" noRot="1" noChangeAspect="1"/>
+          </p:cNvSpPr>
+          <p:nvPr>
+            <p:ph type="sldImg"/>
+          </p:nvPr>
+        </p:nvSpPr>
+        <p:spPr/>
+      </p:sp>
+      <p:sp>
+        <p:nvSpPr>
+          <p:cNvPr id="3" name="Notizenplatzhalter 2"/>
+          <p:cNvSpPr>
+            <a:spLocks noGrp="1"/>
+          </p:cNvSpPr>
+          <p:nvPr>
+            <p:ph type="body" idx="1"/>
+          </p:nvPr>
+        </p:nvSpPr>
+        <p:spPr/>
+        <p:txBody>
+          <a:bodyPr/>
+          <a:lstStyle/>
+          <a:p>
+            <a:r>
+              <a:rPr lang="en-US"/>
+              <a:t>I’ve participated in this shared task as part of my Master’s Thesis, as such I’ve made some more findings since…</a:t>
+            </a:r>
+            <a:endParaRPr lang="en-AT"/>
+          </a:p>
+        </p:txBody>
+      </p:sp>
+      <p:sp>
+        <p:nvSpPr>
+          <p:cNvPr id="4" name="Foliennummernplatzhalter 3"/>
+          <p:cNvSpPr>
+            <a:spLocks noGrp="1"/>
+          </p:cNvSpPr>
+          <p:nvPr>
+            <p:ph type="sldNum" sz="quarter" idx="5"/>
+          </p:nvPr>
+        </p:nvSpPr>
+        <p:spPr/>
+        <p:txBody>
+          <a:bodyPr/>
+          <a:lstStyle/>
+          <a:p>
+            <a:fld id="{4B7EC79C-4F4E-40A6-BD42-D4E6BA83A575}" type="slidenum">
+              <a:rPr lang="en-AT" smtClean="0"/>
+              <a:t>19</a:t>
+            </a:fld>
+            <a:endParaRPr lang="en-AT"/>
+          </a:p>
+        </p:txBody>
+      </p:sp>
+    </p:spTree>
+    <p:extLst>
+      <p:ext uri="{BB962C8B-B14F-4D97-AF65-F5344CB8AC3E}">
+        <p14:creationId xmlns:p14="http://schemas.microsoft.com/office/powerpoint/2010/main" val="1943403197"/>
       </p:ext>
     </p:extLst>
   </p:cSld>
@@ -627,10 +1391,10 @@
           <a:lstStyle/>
           <a:p>
             <a:r>
-              <a:rPr lang="en-US" dirty="0"/>
+              <a:rPr lang="en-US"/>
               <a:t>This is our approach, and I’ll walk you through it as we move through this talk.</a:t>
             </a:r>
-            <a:endParaRPr lang="en-AT" dirty="0"/>
+            <a:endParaRPr lang="en-AT"/>
           </a:p>
         </p:txBody>
       </p:sp>
@@ -715,10 +1479,10 @@
           <a:lstStyle/>
           <a:p>
             <a:r>
-              <a:rPr lang="en-US" dirty="0"/>
+              <a:rPr lang="en-US"/>
               <a:t>First off, let’s start with the data. You’re already familiar with the task, so let’s just get a quick look at the data.</a:t>
             </a:r>
-            <a:endParaRPr lang="en-AT" dirty="0"/>
+            <a:endParaRPr lang="en-AT"/>
           </a:p>
         </p:txBody>
       </p:sp>
@@ -803,10 +1567,10 @@
           <a:lstStyle/>
           <a:p>
             <a:r>
-              <a:rPr lang="en-US" dirty="0"/>
+              <a:rPr lang="en-US"/>
               <a:t>This is what a rumor from the dataset looks like…</a:t>
             </a:r>
-            <a:endParaRPr lang="en-AT" dirty="0"/>
+            <a:endParaRPr lang="en-AT"/>
           </a:p>
         </p:txBody>
       </p:sp>
@@ -891,16 +1655,16 @@
           <a:lstStyle/>
           <a:p>
             <a:r>
-              <a:rPr lang="en-US" dirty="0"/>
+              <a:rPr lang="en-US"/>
               <a:t>…but we can get some extra data from here. The claim is “anonymous”, but the Authority Account is not. So, we got the Display Name and Bio from Twitter, and wanted to see if we can improve results.</a:t>
             </a:r>
           </a:p>
           <a:p>
             <a:r>
-              <a:rPr lang="en-US" dirty="0"/>
+              <a:rPr lang="en-US"/>
               <a:t>We can also test if preprocessing could be beneficial.</a:t>
             </a:r>
-            <a:endParaRPr lang="en-AT" dirty="0"/>
+            <a:endParaRPr lang="en-AT"/>
           </a:p>
         </p:txBody>
       </p:sp>
@@ -985,10 +1749,10 @@
           <a:lstStyle/>
           <a:p>
             <a:r>
-              <a:rPr lang="en-US" dirty="0"/>
+              <a:rPr lang="en-US"/>
               <a:t>Once we have the timelines ready, we need to pick our Evidence we can use later. This is the Retrieval step. Let’s take a look.</a:t>
             </a:r>
-            <a:endParaRPr lang="en-AT" dirty="0"/>
+            <a:endParaRPr lang="en-AT"/>
           </a:p>
         </p:txBody>
       </p:sp>
@@ -1073,10 +1837,90 @@
           <a:lstStyle/>
           <a:p>
             <a:r>
-              <a:rPr lang="en-US" dirty="0"/>
-              <a:t>I’ve participated in this shared task as part of my Master’s Thesis, as such I’ve made some more findings since…</a:t>
-            </a:r>
-            <a:endParaRPr lang="en-AT" dirty="0"/>
+              <a:rPr lang="de-DE" dirty="0"/>
+              <a:t>Next, </a:t>
+            </a:r>
+            <a:r>
+              <a:rPr lang="de-DE" dirty="0" err="1"/>
+              <a:t>we</a:t>
+            </a:r>
+            <a:r>
+              <a:rPr lang="de-DE" dirty="0"/>
+              <a:t> </a:t>
+            </a:r>
+            <a:r>
+              <a:rPr lang="de-DE" dirty="0" err="1"/>
+              <a:t>use</a:t>
+            </a:r>
+            <a:r>
+              <a:rPr lang="de-DE" dirty="0"/>
+              <a:t> </a:t>
+            </a:r>
+            <a:r>
+              <a:rPr lang="de-DE" dirty="0" err="1"/>
+              <a:t>the</a:t>
+            </a:r>
+            <a:r>
+              <a:rPr lang="de-DE" dirty="0"/>
+              <a:t> </a:t>
+            </a:r>
+            <a:r>
+              <a:rPr lang="de-DE" dirty="0" err="1"/>
+              <a:t>Evidence</a:t>
+            </a:r>
+            <a:r>
+              <a:rPr lang="de-DE" dirty="0"/>
+              <a:t> </a:t>
+            </a:r>
+            <a:r>
+              <a:rPr lang="de-DE" dirty="0" err="1"/>
+              <a:t>to</a:t>
+            </a:r>
+            <a:r>
+              <a:rPr lang="de-DE" dirty="0"/>
+              <a:t> </a:t>
+            </a:r>
+            <a:r>
+              <a:rPr lang="de-DE" dirty="0" err="1"/>
+              <a:t>predict</a:t>
+            </a:r>
+            <a:r>
+              <a:rPr lang="de-DE" dirty="0"/>
+              <a:t> a „</a:t>
+            </a:r>
+            <a:r>
+              <a:rPr lang="de-DE" dirty="0" err="1"/>
+              <a:t>Judgement</a:t>
+            </a:r>
+            <a:r>
+              <a:rPr lang="de-DE" dirty="0"/>
+              <a:t>“ </a:t>
+            </a:r>
+            <a:r>
+              <a:rPr lang="de-DE" dirty="0" err="1"/>
+              <a:t>for</a:t>
+            </a:r>
+            <a:r>
+              <a:rPr lang="de-DE" dirty="0"/>
+              <a:t> </a:t>
+            </a:r>
+            <a:r>
+              <a:rPr lang="de-DE" dirty="0" err="1"/>
+              <a:t>each</a:t>
+            </a:r>
+            <a:r>
+              <a:rPr lang="de-DE" dirty="0"/>
+              <a:t> </a:t>
+            </a:r>
+            <a:r>
+              <a:rPr lang="de-DE" dirty="0" err="1"/>
+              <a:t>claim-evidence</a:t>
+            </a:r>
+            <a:r>
+              <a:rPr lang="de-DE" dirty="0"/>
+              <a:t> pair</a:t>
+            </a:r>
+            <a:endParaRPr lang="de-AT" dirty="0"/>
           </a:p>
         </p:txBody>
       </p:sp>
@@ -1097,7 +1941,7 @@
           <a:p>
             <a:fld id="{4B7EC79C-4F4E-40A6-BD42-D4E6BA83A575}" type="slidenum">
               <a:rPr lang="en-AT" smtClean="0"/>
-              <a:t>18</a:t>
+              <a:t>9</a:t>
             </a:fld>
             <a:endParaRPr lang="en-AT"/>
           </a:p>
@@ -1106,7 +1950,7 @@
     </p:spTree>
     <p:extLst>
       <p:ext uri="{BB962C8B-B14F-4D97-AF65-F5344CB8AC3E}">
-        <p14:creationId xmlns:p14="http://schemas.microsoft.com/office/powerpoint/2010/main" val="3232905122"/>
+        <p14:creationId xmlns:p14="http://schemas.microsoft.com/office/powerpoint/2010/main" val="1024275708"/>
       </p:ext>
     </p:extLst>
   </p:cSld>
@@ -1161,10 +2005,174 @@
           <a:lstStyle/>
           <a:p>
             <a:r>
-              <a:rPr lang="en-US" dirty="0"/>
-              <a:t>I’ve participated in this shared task as part of my Master’s Thesis, as such I’ve made some more findings since…</a:t>
-            </a:r>
-            <a:endParaRPr lang="en-AT" dirty="0"/>
+              <a:rPr lang="de-DE" dirty="0" err="1"/>
+              <a:t>Since</a:t>
+            </a:r>
+            <a:r>
+              <a:rPr lang="de-DE" dirty="0"/>
+              <a:t> </a:t>
+            </a:r>
+            <a:r>
+              <a:rPr lang="de-DE" dirty="0" err="1"/>
+              <a:t>we</a:t>
+            </a:r>
+            <a:r>
+              <a:rPr lang="de-DE" dirty="0"/>
+              <a:t> </a:t>
+            </a:r>
+            <a:r>
+              <a:rPr lang="de-DE" dirty="0" err="1"/>
+              <a:t>have</a:t>
+            </a:r>
+            <a:r>
+              <a:rPr lang="de-DE" dirty="0"/>
+              <a:t> </a:t>
+            </a:r>
+            <a:r>
+              <a:rPr lang="de-DE" dirty="0" err="1"/>
+              <a:t>the</a:t>
+            </a:r>
+            <a:r>
+              <a:rPr lang="de-DE" dirty="0"/>
+              <a:t> </a:t>
+            </a:r>
+            <a:r>
+              <a:rPr lang="de-DE" dirty="0" err="1"/>
+              <a:t>actual</a:t>
+            </a:r>
+            <a:r>
+              <a:rPr lang="de-DE" dirty="0"/>
+              <a:t> Ground Truth </a:t>
+            </a:r>
+            <a:r>
+              <a:rPr lang="de-DE" dirty="0" err="1"/>
+              <a:t>available</a:t>
+            </a:r>
+            <a:r>
+              <a:rPr lang="de-DE" dirty="0"/>
+              <a:t> </a:t>
+            </a:r>
+            <a:r>
+              <a:rPr lang="de-DE" dirty="0" err="1"/>
+              <a:t>for</a:t>
+            </a:r>
+            <a:r>
+              <a:rPr lang="de-DE" dirty="0"/>
+              <a:t> </a:t>
+            </a:r>
+            <a:r>
+              <a:rPr lang="de-DE" dirty="0" err="1"/>
+              <a:t>the</a:t>
+            </a:r>
+            <a:r>
+              <a:rPr lang="de-DE" dirty="0"/>
+              <a:t> TRAIN and DEV </a:t>
+            </a:r>
+            <a:r>
+              <a:rPr lang="de-DE" dirty="0" err="1"/>
+              <a:t>set</a:t>
+            </a:r>
+            <a:r>
+              <a:rPr lang="de-DE" dirty="0"/>
+              <a:t>, </a:t>
+            </a:r>
+            <a:r>
+              <a:rPr lang="de-DE" dirty="0" err="1"/>
+              <a:t>we</a:t>
+            </a:r>
+            <a:r>
+              <a:rPr lang="de-DE" dirty="0"/>
+              <a:t> </a:t>
+            </a:r>
+            <a:r>
+              <a:rPr lang="de-DE" dirty="0" err="1"/>
+              <a:t>can</a:t>
+            </a:r>
+            <a:r>
+              <a:rPr lang="de-DE" dirty="0"/>
+              <a:t> </a:t>
+            </a:r>
+            <a:r>
+              <a:rPr lang="de-DE" dirty="0" err="1"/>
+              <a:t>evaluate</a:t>
+            </a:r>
+            <a:r>
+              <a:rPr lang="de-DE" dirty="0"/>
+              <a:t> </a:t>
+            </a:r>
+            <a:r>
+              <a:rPr lang="de-DE" dirty="0" err="1"/>
+              <a:t>the</a:t>
+            </a:r>
+            <a:r>
+              <a:rPr lang="de-DE" dirty="0"/>
+              <a:t> </a:t>
+            </a:r>
+            <a:r>
+              <a:rPr lang="de-DE" dirty="0" err="1"/>
+              <a:t>performance</a:t>
+            </a:r>
+            <a:r>
+              <a:rPr lang="de-DE" dirty="0"/>
+              <a:t> </a:t>
+            </a:r>
+            <a:r>
+              <a:rPr lang="de-DE" dirty="0" err="1"/>
+              <a:t>of</a:t>
+            </a:r>
+            <a:r>
+              <a:rPr lang="de-DE" dirty="0"/>
+              <a:t> </a:t>
+            </a:r>
+            <a:r>
+              <a:rPr lang="de-DE" dirty="0" err="1"/>
+              <a:t>our</a:t>
+            </a:r>
+            <a:r>
+              <a:rPr lang="de-DE" dirty="0"/>
+              <a:t> </a:t>
+            </a:r>
+            <a:r>
+              <a:rPr lang="de-DE" dirty="0" err="1"/>
+              <a:t>proposed</a:t>
+            </a:r>
+            <a:r>
+              <a:rPr lang="de-DE" dirty="0"/>
+              <a:t> </a:t>
+            </a:r>
+            <a:r>
+              <a:rPr lang="de-DE" dirty="0" err="1"/>
+              <a:t>setups</a:t>
+            </a:r>
+            <a:r>
+              <a:rPr lang="de-DE" dirty="0"/>
+              <a:t> </a:t>
+            </a:r>
+            <a:r>
+              <a:rPr lang="de-DE" dirty="0" err="1"/>
+              <a:t>against</a:t>
+            </a:r>
+            <a:r>
+              <a:rPr lang="de-DE" dirty="0"/>
+              <a:t> </a:t>
+            </a:r>
+            <a:r>
+              <a:rPr lang="de-DE" dirty="0" err="1"/>
+              <a:t>each</a:t>
+            </a:r>
+            <a:r>
+              <a:rPr lang="de-DE" dirty="0"/>
+              <a:t> </a:t>
+            </a:r>
+            <a:r>
+              <a:rPr lang="de-DE" dirty="0" err="1"/>
+              <a:t>other</a:t>
+            </a:r>
+            <a:r>
+              <a:rPr lang="de-DE" dirty="0"/>
+              <a:t>…</a:t>
+            </a:r>
+            <a:endParaRPr lang="de-AT" dirty="0"/>
           </a:p>
         </p:txBody>
       </p:sp>
@@ -1185,7 +2193,7 @@
           <a:p>
             <a:fld id="{4B7EC79C-4F4E-40A6-BD42-D4E6BA83A575}" type="slidenum">
               <a:rPr lang="en-AT" smtClean="0"/>
-              <a:t>19</a:t>
+              <a:t>11</a:t>
             </a:fld>
             <a:endParaRPr lang="en-AT"/>
           </a:p>
@@ -1194,7 +2202,235 @@
     </p:spTree>
     <p:extLst>
       <p:ext uri="{BB962C8B-B14F-4D97-AF65-F5344CB8AC3E}">
-        <p14:creationId xmlns:p14="http://schemas.microsoft.com/office/powerpoint/2010/main" val="1943403197"/>
+        <p14:creationId xmlns:p14="http://schemas.microsoft.com/office/powerpoint/2010/main" val="2323907225"/>
+      </p:ext>
+    </p:extLst>
+  </p:cSld>
+  <p:clrMapOvr>
+    <a:masterClrMapping/>
+  </p:clrMapOvr>
+</p:notes>
+</file>
+
+<file path=ppt/notesSlides/notesSlide9.xml><?xml version="1.0" encoding="utf-8"?>
+<p:notes xmlns:a="http://schemas.openxmlformats.org/drawingml/2006/main" xmlns:r="http://schemas.openxmlformats.org/officeDocument/2006/relationships" xmlns:p="http://schemas.openxmlformats.org/presentationml/2006/main">
+  <p:cSld>
+    <p:spTree>
+      <p:nvGrpSpPr>
+        <p:cNvPr id="1" name=""/>
+        <p:cNvGrpSpPr/>
+        <p:nvPr/>
+      </p:nvGrpSpPr>
+      <p:grpSpPr>
+        <a:xfrm>
+          <a:off x="0" y="0"/>
+          <a:ext cx="0" cy="0"/>
+          <a:chOff x="0" y="0"/>
+          <a:chExt cx="0" cy="0"/>
+        </a:xfrm>
+      </p:grpSpPr>
+      <p:sp>
+        <p:nvSpPr>
+          <p:cNvPr id="2" name="Folienbildplatzhalter 1"/>
+          <p:cNvSpPr>
+            <a:spLocks noGrp="1" noRot="1" noChangeAspect="1"/>
+          </p:cNvSpPr>
+          <p:nvPr>
+            <p:ph type="sldImg"/>
+          </p:nvPr>
+        </p:nvSpPr>
+        <p:spPr/>
+      </p:sp>
+      <p:sp>
+        <p:nvSpPr>
+          <p:cNvPr id="3" name="Notizenplatzhalter 2"/>
+          <p:cNvSpPr>
+            <a:spLocks noGrp="1"/>
+          </p:cNvSpPr>
+          <p:nvPr>
+            <p:ph type="body" idx="1"/>
+          </p:nvPr>
+        </p:nvSpPr>
+        <p:spPr/>
+        <p:txBody>
+          <a:bodyPr/>
+          <a:lstStyle/>
+          <a:p>
+            <a:r>
+              <a:rPr lang="de-DE" dirty="0" err="1"/>
+              <a:t>Our</a:t>
+            </a:r>
+            <a:r>
+              <a:rPr lang="de-DE" dirty="0"/>
+              <a:t> </a:t>
+            </a:r>
+            <a:r>
+              <a:rPr lang="de-DE" dirty="0" err="1"/>
+              <a:t>performance</a:t>
+            </a:r>
+            <a:r>
+              <a:rPr lang="de-DE" dirty="0"/>
+              <a:t> was </a:t>
+            </a:r>
+            <a:r>
+              <a:rPr lang="de-DE" dirty="0" err="1"/>
+              <a:t>pretty</a:t>
+            </a:r>
+            <a:r>
+              <a:rPr lang="de-DE" dirty="0"/>
+              <a:t> </a:t>
+            </a:r>
+            <a:r>
+              <a:rPr lang="de-DE" dirty="0" err="1"/>
+              <a:t>bad</a:t>
+            </a:r>
+            <a:r>
+              <a:rPr lang="de-DE" dirty="0"/>
+              <a:t>, </a:t>
+            </a:r>
+            <a:r>
+              <a:rPr lang="de-DE" dirty="0" err="1"/>
+              <a:t>since</a:t>
+            </a:r>
+            <a:r>
+              <a:rPr lang="de-DE" dirty="0"/>
+              <a:t> </a:t>
+            </a:r>
+            <a:r>
+              <a:rPr lang="de-DE" dirty="0" err="1"/>
+              <a:t>the</a:t>
+            </a:r>
+            <a:r>
+              <a:rPr lang="de-DE" dirty="0"/>
+              <a:t> </a:t>
+            </a:r>
+            <a:r>
+              <a:rPr lang="de-DE" dirty="0" err="1"/>
+              <a:t>OpenAI</a:t>
+            </a:r>
+            <a:r>
+              <a:rPr lang="de-DE" dirty="0"/>
+              <a:t> </a:t>
+            </a:r>
+            <a:r>
+              <a:rPr lang="de-DE" dirty="0" err="1"/>
+              <a:t>Embeddings</a:t>
+            </a:r>
+            <a:r>
+              <a:rPr lang="de-DE" dirty="0"/>
+              <a:t> </a:t>
+            </a:r>
+            <a:r>
+              <a:rPr lang="de-DE" dirty="0" err="1"/>
+              <a:t>we</a:t>
+            </a:r>
+            <a:r>
+              <a:rPr lang="de-DE" dirty="0"/>
+              <a:t> </a:t>
+            </a:r>
+            <a:r>
+              <a:rPr lang="de-DE" dirty="0" err="1"/>
+              <a:t>used</a:t>
+            </a:r>
+            <a:r>
+              <a:rPr lang="de-DE" dirty="0"/>
+              <a:t> </a:t>
+            </a:r>
+            <a:r>
+              <a:rPr lang="de-DE" dirty="0" err="1"/>
+              <a:t>were</a:t>
+            </a:r>
+            <a:r>
+              <a:rPr lang="de-DE" dirty="0"/>
+              <a:t> not </a:t>
+            </a:r>
+            <a:r>
+              <a:rPr lang="de-DE" dirty="0" err="1"/>
+              <a:t>quite</a:t>
+            </a:r>
+            <a:r>
+              <a:rPr lang="de-DE" dirty="0"/>
+              <a:t> </a:t>
+            </a:r>
+            <a:r>
+              <a:rPr lang="de-DE" dirty="0" err="1"/>
+              <a:t>suited</a:t>
+            </a:r>
+            <a:r>
+              <a:rPr lang="de-DE" dirty="0"/>
+              <a:t> </a:t>
+            </a:r>
+            <a:r>
+              <a:rPr lang="de-DE" dirty="0" err="1"/>
+              <a:t>to</a:t>
+            </a:r>
+            <a:r>
+              <a:rPr lang="de-DE" dirty="0"/>
+              <a:t> </a:t>
+            </a:r>
+            <a:r>
+              <a:rPr lang="de-DE" dirty="0" err="1"/>
+              <a:t>the</a:t>
+            </a:r>
+            <a:r>
+              <a:rPr lang="de-DE" dirty="0"/>
+              <a:t> </a:t>
+            </a:r>
+            <a:r>
+              <a:rPr lang="de-DE" dirty="0" err="1"/>
+              <a:t>task</a:t>
+            </a:r>
+            <a:r>
+              <a:rPr lang="de-DE" dirty="0"/>
+              <a:t> and </a:t>
+            </a:r>
+            <a:r>
+              <a:rPr lang="de-DE" dirty="0" err="1"/>
+              <a:t>PyTerrier</a:t>
+            </a:r>
+            <a:r>
+              <a:rPr lang="de-DE" dirty="0"/>
+              <a:t> ist </a:t>
+            </a:r>
+            <a:r>
+              <a:rPr lang="de-DE" dirty="0" err="1"/>
+              <a:t>basically</a:t>
+            </a:r>
+            <a:r>
+              <a:rPr lang="de-DE" dirty="0"/>
+              <a:t> just PL2</a:t>
+            </a:r>
+            <a:endParaRPr lang="de-AT" dirty="0"/>
+          </a:p>
+        </p:txBody>
+      </p:sp>
+      <p:sp>
+        <p:nvSpPr>
+          <p:cNvPr id="4" name="Foliennummernplatzhalter 3"/>
+          <p:cNvSpPr>
+            <a:spLocks noGrp="1"/>
+          </p:cNvSpPr>
+          <p:nvPr>
+            <p:ph type="sldNum" sz="quarter" idx="5"/>
+          </p:nvPr>
+        </p:nvSpPr>
+        <p:spPr/>
+        <p:txBody>
+          <a:bodyPr/>
+          <a:lstStyle/>
+          <a:p>
+            <a:fld id="{4B7EC79C-4F4E-40A6-BD42-D4E6BA83A575}" type="slidenum">
+              <a:rPr lang="en-AT" smtClean="0"/>
+              <a:t>13</a:t>
+            </a:fld>
+            <a:endParaRPr lang="en-AT"/>
+          </a:p>
+        </p:txBody>
+      </p:sp>
+    </p:spTree>
+    <p:extLst>
+      <p:ext uri="{BB962C8B-B14F-4D97-AF65-F5344CB8AC3E}">
+        <p14:creationId xmlns:p14="http://schemas.microsoft.com/office/powerpoint/2010/main" val="2551892973"/>
       </p:ext>
     </p:extLst>
   </p:cSld>
@@ -1351,7 +2587,7 @@
           <a:p>
             <a:fld id="{AD69E3B9-6DDF-4AE3-942F-197004E2B325}" type="datetime1">
               <a:rPr lang="en-US" smtClean="0"/>
-              <a:t>9/4/2024</a:t>
+              <a:t>9/10/2024</a:t>
             </a:fld>
             <a:endParaRPr lang="en-US"/>
           </a:p>
@@ -1549,7 +2785,7 @@
           <a:p>
             <a:fld id="{B8FC674A-7C45-43C2-BAA2-664DA443B8BE}" type="datetime1">
               <a:rPr lang="en-US" smtClean="0"/>
-              <a:t>9/4/2024</a:t>
+              <a:t>9/10/2024</a:t>
             </a:fld>
             <a:endParaRPr lang="en-US"/>
           </a:p>
@@ -1757,7 +2993,7 @@
           <a:p>
             <a:fld id="{0E28963E-B020-4BC6-82A4-3E04E380B704}" type="datetime1">
               <a:rPr lang="en-US" smtClean="0"/>
-              <a:t>9/4/2024</a:t>
+              <a:t>9/10/2024</a:t>
             </a:fld>
             <a:endParaRPr lang="en-US"/>
           </a:p>
@@ -1872,7 +3108,6 @@
               <a:rPr lang="en-US"/>
               <a:t>Click to edit Master title style</a:t>
             </a:r>
-            <a:endParaRPr lang="en-US" dirty="0"/>
           </a:p>
         </p:txBody>
       </p:sp>
@@ -1956,7 +3191,7 @@
           <a:p>
             <a:fld id="{BB50379A-DD18-42EC-9876-3DAAEF0B475E}" type="datetime1">
               <a:rPr lang="en-US" smtClean="0"/>
-              <a:t>9/4/2024</a:t>
+              <a:t>9/10/2024</a:t>
             </a:fld>
             <a:endParaRPr lang="en-US"/>
           </a:p>
@@ -2231,7 +3466,7 @@
           <a:p>
             <a:fld id="{56B018B4-34DD-4FAD-860A-78BA2DDAC777}" type="datetime1">
               <a:rPr lang="en-US" smtClean="0"/>
-              <a:t>9/4/2024</a:t>
+              <a:t>9/10/2024</a:t>
             </a:fld>
             <a:endParaRPr lang="en-US"/>
           </a:p>
@@ -2496,7 +3731,7 @@
           <a:p>
             <a:fld id="{E93488C2-16FA-42E9-B56A-BBCEBB0C23B9}" type="datetime1">
               <a:rPr lang="en-US" smtClean="0"/>
-              <a:t>9/4/2024</a:t>
+              <a:t>9/10/2024</a:t>
             </a:fld>
             <a:endParaRPr lang="en-US"/>
           </a:p>
@@ -2908,7 +4143,7 @@
           <a:p>
             <a:fld id="{9836A149-B6DE-4D40-88CC-D5886D7EAC21}" type="datetime1">
               <a:rPr lang="en-US" smtClean="0"/>
-              <a:t>9/4/2024</a:t>
+              <a:t>9/10/2024</a:t>
             </a:fld>
             <a:endParaRPr lang="en-US"/>
           </a:p>
@@ -3049,7 +4284,7 @@
           <a:p>
             <a:fld id="{D0F60488-CF6A-4385-98C7-A97DBA2C1051}" type="datetime1">
               <a:rPr lang="en-US" smtClean="0"/>
-              <a:t>9/4/2024</a:t>
+              <a:t>9/10/2024</a:t>
             </a:fld>
             <a:endParaRPr lang="en-US"/>
           </a:p>
@@ -3162,7 +4397,7 @@
           <a:p>
             <a:fld id="{9B00AF08-1976-4C74-AFC2-4E4BBAFB4EF8}" type="datetime1">
               <a:rPr lang="en-US" smtClean="0"/>
-              <a:t>9/4/2024</a:t>
+              <a:t>9/10/2024</a:t>
             </a:fld>
             <a:endParaRPr lang="en-US"/>
           </a:p>
@@ -3286,7 +4521,6 @@
               <a:rPr lang="en-US"/>
               <a:t>Click to edit Master title style</a:t>
             </a:r>
-            <a:endParaRPr lang="en-US" dirty="0"/>
           </a:p>
         </p:txBody>
       </p:sp>
@@ -3474,7 +4708,7 @@
           <a:p>
             <a:fld id="{ACA8A65E-3922-4D9A-8A42-4EE7C068417E}" type="datetime1">
               <a:rPr lang="en-US" smtClean="0"/>
-              <a:t>9/4/2024</a:t>
+              <a:t>9/10/2024</a:t>
             </a:fld>
             <a:endParaRPr lang="en-US"/>
           </a:p>
@@ -3765,7 +4999,7 @@
           <a:p>
             <a:fld id="{AF1DBBCE-1A87-49A5-8A8E-6ECA7D2CE351}" type="datetime1">
               <a:rPr lang="en-US" smtClean="0"/>
-              <a:t>9/4/2024</a:t>
+              <a:t>9/10/2024</a:t>
             </a:fld>
             <a:endParaRPr lang="en-US"/>
           </a:p>
@@ -4032,7 +5266,7 @@
               <a:tabLst/>
               <a:defRPr/>
             </a:pPr>
-            <a:endParaRPr kumimoji="0" lang="en-US" sz="1500" b="0" i="0" u="none" strike="noStrike" kern="1200" cap="none" spc="0" normalizeH="0" baseline="0" noProof="0" dirty="0">
+            <a:endParaRPr kumimoji="0" lang="en-US" sz="1500" b="0" i="0" u="none" strike="noStrike" kern="1200" cap="none" spc="0" normalizeH="0" baseline="0" noProof="0">
               <a:ln>
                 <a:noFill/>
               </a:ln>
@@ -4411,7 +5645,6 @@
               <a:rPr lang="en-US"/>
               <a:t>Click to edit Master title style</a:t>
             </a:r>
-            <a:endParaRPr lang="en-US" dirty="0"/>
           </a:p>
         </p:txBody>
       </p:sp>
@@ -4448,38 +5681,37 @@
           <a:p>
             <a:pPr lvl="0"/>
             <a:r>
-              <a:rPr lang="en-US"/>
+              <a:rPr lang="en-US" dirty="0"/>
               <a:t>Click to edit Master text styles</a:t>
             </a:r>
           </a:p>
           <a:p>
             <a:pPr lvl="1"/>
             <a:r>
-              <a:rPr lang="en-US"/>
+              <a:rPr lang="en-US" dirty="0"/>
               <a:t>Second level</a:t>
             </a:r>
           </a:p>
           <a:p>
             <a:pPr lvl="2"/>
             <a:r>
-              <a:rPr lang="en-US"/>
+              <a:rPr lang="en-US" dirty="0"/>
               <a:t>Third level</a:t>
             </a:r>
           </a:p>
           <a:p>
             <a:pPr lvl="3"/>
             <a:r>
-              <a:rPr lang="en-US"/>
+              <a:rPr lang="en-US" dirty="0"/>
               <a:t>Fourth level</a:t>
             </a:r>
           </a:p>
           <a:p>
             <a:pPr lvl="4"/>
             <a:r>
-              <a:rPr lang="en-US"/>
+              <a:rPr lang="en-US" dirty="0"/>
               <a:t>Fifth level</a:t>
             </a:r>
-            <a:endParaRPr lang="en-US" dirty="0"/>
           </a:p>
         </p:txBody>
       </p:sp>
@@ -4525,7 +5757,7 @@
           <a:p>
             <a:fld id="{ED3A328E-E399-4DC7-9F95-168ED6EC86EB}" type="datetime1">
               <a:rPr lang="en-US" smtClean="0"/>
-              <a:t>9/4/2024</a:t>
+              <a:t>9/10/2024</a:t>
             </a:fld>
             <a:endParaRPr lang="en-US"/>
           </a:p>
@@ -4571,7 +5803,7 @@
             </a:lvl1pPr>
           </a:lstStyle>
           <a:p>
-            <a:endParaRPr lang="en-US" dirty="0"/>
+            <a:endParaRPr lang="en-US"/>
           </a:p>
         </p:txBody>
       </p:sp>
@@ -4620,7 +5852,7 @@
               <a:pPr/>
               <a:t>‹Nr.›</a:t>
             </a:fld>
-            <a:endParaRPr lang="en-US" dirty="0"/>
+            <a:endParaRPr lang="en-US"/>
           </a:p>
         </p:txBody>
       </p:sp>
@@ -4714,9 +5946,7 @@
         <a:buChar char="•"/>
         <a:defRPr sz="2800" kern="1200">
           <a:solidFill>
-            <a:schemeClr val="tx1">
-              <a:alpha val="70000"/>
-            </a:schemeClr>
+            <a:srgbClr val="FFFFFF"/>
           </a:solidFill>
           <a:latin typeface="+mn-lt"/>
           <a:ea typeface="+mn-ea"/>
@@ -4734,9 +5964,7 @@
         <a:buChar char="•"/>
         <a:defRPr sz="2400" kern="1200">
           <a:solidFill>
-            <a:schemeClr val="tx1">
-              <a:alpha val="70000"/>
-            </a:schemeClr>
+            <a:srgbClr val="FFFFFF"/>
           </a:solidFill>
           <a:latin typeface="+mn-lt"/>
           <a:ea typeface="+mn-ea"/>
@@ -4754,9 +5982,7 @@
         <a:buChar char="•"/>
         <a:defRPr sz="2000" kern="1200">
           <a:solidFill>
-            <a:schemeClr val="tx1">
-              <a:alpha val="70000"/>
-            </a:schemeClr>
+            <a:srgbClr val="FFFFFF"/>
           </a:solidFill>
           <a:latin typeface="+mn-lt"/>
           <a:ea typeface="+mn-ea"/>
@@ -4774,9 +6000,7 @@
         <a:buChar char="•"/>
         <a:defRPr sz="1800" kern="1200">
           <a:solidFill>
-            <a:schemeClr val="tx1">
-              <a:alpha val="70000"/>
-            </a:schemeClr>
+            <a:srgbClr val="FFFFFF"/>
           </a:solidFill>
           <a:latin typeface="+mn-lt"/>
           <a:ea typeface="+mn-ea"/>
@@ -4794,9 +6018,7 @@
         <a:buChar char="•"/>
         <a:defRPr sz="1800" kern="1200">
           <a:solidFill>
-            <a:schemeClr val="tx1">
-              <a:alpha val="70000"/>
-            </a:schemeClr>
+            <a:srgbClr val="FFFFFF"/>
           </a:solidFill>
           <a:latin typeface="+mn-lt"/>
           <a:ea typeface="+mn-ea"/>
@@ -5063,7 +6285,7 @@
           <a:bodyPr rtlCol="0" anchor="ctr"/>
           <a:lstStyle/>
           <a:p>
-            <a:endParaRPr lang="en-US" dirty="0"/>
+            <a:endParaRPr lang="en-US"/>
           </a:p>
         </p:txBody>
       </p:sp>
@@ -5085,7 +6307,7 @@
         </p:spPr>
         <p:txBody>
           <a:bodyPr>
-            <a:normAutofit/>
+            <a:normAutofit fontScale="90000"/>
           </a:bodyPr>
           <a:lstStyle/>
           <a:p>
@@ -5108,8 +6330,27 @@
                 <a:latin typeface="Bahnschrift"/>
                 <a:cs typeface="Arial"/>
               </a:rPr>
-              <a:t>CheckThat! 2024 Task 5</a:t>
-            </a:r>
+              <a:t>CheckThat! 2024 </a:t>
+            </a:r>
+            <a:br>
+              <a:rPr lang="en-US" sz="3400" b="1" dirty="0">
+                <a:latin typeface="Bahnschrift"/>
+                <a:cs typeface="Arial"/>
+              </a:rPr>
+            </a:br>
+            <a:r>
+              <a:rPr lang="en-US" sz="3400" b="1" dirty="0">
+                <a:latin typeface="Bahnschrift"/>
+                <a:cs typeface="Arial"/>
+              </a:rPr>
+              <a:t>Task 5</a:t>
+            </a:r>
+            <a:br>
+              <a:rPr lang="en-US" sz="3400" b="1" dirty="0">
+                <a:latin typeface="Bahnschrift"/>
+                <a:cs typeface="Arial"/>
+              </a:rPr>
+            </a:br>
             <a:br>
               <a:rPr lang="en-US" sz="3400" b="1" dirty="0">
                 <a:latin typeface="Bahnschrift"/>
@@ -5181,7 +6422,14 @@
                 <a:latin typeface="Bahnschrift"/>
                 <a:cs typeface="Arial"/>
               </a:rPr>
-              <a:t>, Allan Hanbury </a:t>
+              <a:t>, </a:t>
+            </a:r>
+            <a:r>
+              <a:rPr lang="en-US" sz="2000" dirty="0">
+                <a:latin typeface="Bahnschrift"/>
+                <a:cs typeface="Arial"/>
+              </a:rPr>
+              <a:t>Allan Hanbury </a:t>
             </a:r>
             <a:endParaRPr lang="de-DE" dirty="0">
               <a:solidFill>
@@ -5223,6 +6471,9 @@
             <a:extLst>
               <a:ext uri="{FF2B5EF4-FFF2-40B4-BE49-F238E27FC236}">
                 <a16:creationId xmlns:a16="http://schemas.microsoft.com/office/drawing/2014/main" id="{B6ED0F51-6600-3167-9840-902A4376E5BE}"/>
+              </a:ext>
+              <a:ext uri="{C183D7F6-B498-43B3-948B-1728B52AA6E4}">
+                <adec:decorative xmlns:adec="http://schemas.microsoft.com/office/drawing/2017/decorative" val="1"/>
               </a:ext>
             </a:extLst>
           </p:cNvPr>
@@ -5475,7 +6726,7 @@
           <a:lstStyle/>
           <a:p>
             <a:pPr algn="ctr"/>
-            <a:endParaRPr lang="en-US" dirty="0">
+            <a:endParaRPr lang="en-US">
               <a:solidFill>
                 <a:prstClr val="white"/>
               </a:solidFill>
@@ -5486,7 +6737,7 @@
       </p:sp>
       <p:pic>
         <p:nvPicPr>
-          <p:cNvPr id="8" name="Grafik 7" descr="Ein Bild, das Text, Schrift, Grafiken, Symbol enthält.&#10;&#10;Automatisch generierte Beschreibung">
+          <p:cNvPr id="8" name="Grafik 7" descr="CLEF logo">
             <a:extLst>
               <a:ext uri="{FF2B5EF4-FFF2-40B4-BE49-F238E27FC236}">
                 <a16:creationId xmlns:a16="http://schemas.microsoft.com/office/drawing/2014/main" id="{767C62DC-AFD5-E53A-DD19-16583B46E670}"/>
@@ -5522,7 +6773,7 @@
       </p:pic>
       <p:pic>
         <p:nvPicPr>
-          <p:cNvPr id="5" name="Grafik 4" descr="Ein Bild, das Text, Schrift, Screenshot, Logo enthält.&#10;&#10;Automatisch generierte Beschreibung">
+          <p:cNvPr id="5" name="Grafik 4" descr="TU Wien logo">
             <a:extLst>
               <a:ext uri="{FF2B5EF4-FFF2-40B4-BE49-F238E27FC236}">
                 <a16:creationId xmlns:a16="http://schemas.microsoft.com/office/drawing/2014/main" id="{9D13973A-30B2-59B3-CAD7-A575762DAC3D}"/>
@@ -5548,7 +6799,7 @@
         </p:blipFill>
         <p:spPr>
           <a:xfrm>
-            <a:off x="9845547" y="4971947"/>
+            <a:off x="9845547" y="5015488"/>
             <a:ext cx="1905545" cy="724107"/>
           </a:xfrm>
           <a:prstGeom prst="rect">
@@ -5581,10 +6832,57 @@
               <a:rPr lang="en-US" smtClean="0"/>
               <a:t>1</a:t>
             </a:fld>
-            <a:endParaRPr lang="en-US"/>
-          </a:p>
-        </p:txBody>
-      </p:sp>
+            <a:endParaRPr lang="en-US" dirty="0"/>
+          </a:p>
+        </p:txBody>
+      </p:sp>
+      <p:pic>
+        <p:nvPicPr>
+          <p:cNvPr id="1026" name="Picture 2">
+            <a:extLst>
+              <a:ext uri="{FF2B5EF4-FFF2-40B4-BE49-F238E27FC236}">
+                <a16:creationId xmlns:a16="http://schemas.microsoft.com/office/drawing/2014/main" id="{7687D220-E697-F4AE-59B2-5CF9B472CB9D}"/>
+              </a:ext>
+            </a:extLst>
+          </p:cNvPr>
+          <p:cNvPicPr>
+            <a:picLocks noChangeAspect="1" noChangeArrowheads="1"/>
+          </p:cNvPicPr>
+          <p:nvPr/>
+        </p:nvPicPr>
+        <p:blipFill>
+          <a:blip r:embed="rId6">
+            <a:extLst>
+              <a:ext uri="{28A0092B-C50C-407E-A947-70E740481C1C}">
+                <a14:useLocalDpi xmlns:a14="http://schemas.microsoft.com/office/drawing/2010/main" val="0"/>
+              </a:ext>
+            </a:extLst>
+          </a:blip>
+          <a:srcRect/>
+          <a:stretch>
+            <a:fillRect/>
+          </a:stretch>
+        </p:blipFill>
+        <p:spPr bwMode="auto">
+          <a:xfrm>
+            <a:off x="9845547" y="1185786"/>
+            <a:ext cx="1432053" cy="1211737"/>
+          </a:xfrm>
+          <a:prstGeom prst="rect">
+            <a:avLst/>
+          </a:prstGeom>
+          <a:noFill/>
+          <a:extLst>
+            <a:ext uri="{909E8E84-426E-40DD-AFC4-6F175D3DCCD1}">
+              <a14:hiddenFill xmlns:a14="http://schemas.microsoft.com/office/drawing/2010/main">
+                <a:solidFill>
+                  <a:srgbClr val="FFFFFF"/>
+                </a:solidFill>
+              </a14:hiddenFill>
+            </a:ext>
+          </a:extLst>
+        </p:spPr>
+      </p:pic>
     </p:spTree>
     <p:extLst>
       <p:ext uri="{BB962C8B-B14F-4D97-AF65-F5344CB8AC3E}">
@@ -5637,10 +6935,10 @@
           <a:lstStyle/>
           <a:p>
             <a:r>
-              <a:rPr lang="en-US" dirty="0"/>
+              <a:rPr lang="en-US"/>
               <a:t>Verification Stage – Strategy and Models</a:t>
             </a:r>
-            <a:endParaRPr lang="en-AT" dirty="0"/>
+            <a:endParaRPr lang="en-AT"/>
           </a:p>
         </p:txBody>
       </p:sp>
@@ -5666,32 +6964,32 @@
           <a:lstStyle/>
           <a:p>
             <a:r>
-              <a:rPr lang="en-US" dirty="0"/>
+              <a:rPr lang="en-US"/>
               <a:t>Verify claim support using retrieved evidence</a:t>
             </a:r>
           </a:p>
           <a:p>
             <a:r>
-              <a:rPr lang="en-US" dirty="0"/>
+              <a:rPr lang="en-US"/>
               <a:t>Basically Natural Language Inference (NLI)</a:t>
             </a:r>
           </a:p>
           <a:p>
             <a:r>
-              <a:rPr lang="en-US" u="sng" dirty="0"/>
+              <a:rPr lang="en-US" u="sng"/>
               <a:t>Models</a:t>
             </a:r>
             <a:r>
-              <a:rPr lang="en-US" dirty="0"/>
+              <a:rPr lang="en-US"/>
               <a:t>: BERT Variants fine-tuned for NLI, GPT-4, Llama-3</a:t>
             </a:r>
           </a:p>
           <a:p>
             <a:r>
-              <a:rPr lang="en-US" dirty="0"/>
+              <a:rPr lang="en-US"/>
               <a:t>Focus on natural language reasoning: how complex would the language model need to be?</a:t>
             </a:r>
-            <a:endParaRPr lang="en-AT" dirty="0"/>
+            <a:endParaRPr lang="en-AT"/>
           </a:p>
         </p:txBody>
       </p:sp>
@@ -5781,16 +7079,16 @@
           <a:lstStyle/>
           <a:p>
             <a:r>
-              <a:rPr lang="en-US" dirty="0"/>
+              <a:rPr lang="en-US"/>
               <a:t>Our Two-Stage Approach</a:t>
             </a:r>
-            <a:endParaRPr lang="de-DE" dirty="0"/>
+            <a:endParaRPr lang="de-DE"/>
           </a:p>
         </p:txBody>
       </p:sp>
       <p:pic>
         <p:nvPicPr>
-          <p:cNvPr id="6" name="Inhaltsplatzhalter 5" descr="Ein Bild, das Text, Screenshot, Diagramm, Schrift enthält.&#10;&#10;Automatisch generierte Beschreibung">
+          <p:cNvPr id="6" name="Inhaltsplatzhalter 5" descr="approach diagram">
             <a:extLst>
               <a:ext uri="{FF2B5EF4-FFF2-40B4-BE49-F238E27FC236}">
                 <a16:creationId xmlns:a16="http://schemas.microsoft.com/office/drawing/2014/main" id="{D57F5F0E-80EF-004C-AA5C-2A040F362508}"/>
@@ -5805,7 +7103,7 @@
           </p:nvPr>
         </p:nvPicPr>
         <p:blipFill>
-          <a:blip r:embed="rId2">
+          <a:blip r:embed="rId3">
             <a:extLst>
               <a:ext uri="{28A0092B-C50C-407E-A947-70E740481C1C}">
                 <a14:useLocalDpi xmlns:a14="http://schemas.microsoft.com/office/drawing/2010/main" val="0"/>
@@ -5829,6 +7127,9 @@
             <a:extLst>
               <a:ext uri="{FF2B5EF4-FFF2-40B4-BE49-F238E27FC236}">
                 <a16:creationId xmlns:a16="http://schemas.microsoft.com/office/drawing/2014/main" id="{4D585186-BC5F-CD4F-3D89-299D677AFDE6}"/>
+              </a:ext>
+              <a:ext uri="{C183D7F6-B498-43B3-948B-1728B52AA6E4}">
+                <adec:decorative xmlns:adec="http://schemas.microsoft.com/office/drawing/2017/decorative" val="1"/>
               </a:ext>
             </a:extLst>
           </p:cNvPr>
@@ -5958,10 +7259,10 @@
           <a:lstStyle/>
           <a:p>
             <a:r>
-              <a:rPr lang="en-US" dirty="0"/>
+              <a:rPr lang="en-US"/>
               <a:t>Performance Metrics (CheckThat! Task 5)</a:t>
             </a:r>
-            <a:endParaRPr lang="en-AT" dirty="0"/>
+            <a:endParaRPr lang="en-AT"/>
           </a:p>
         </p:txBody>
       </p:sp>
@@ -5987,31 +7288,31 @@
           <a:lstStyle/>
           <a:p>
             <a:r>
-              <a:rPr lang="en-US" u="sng" dirty="0"/>
+              <a:rPr lang="en-US" u="sng"/>
               <a:t>Retrieval</a:t>
             </a:r>
             <a:r>
-              <a:rPr lang="en-US" dirty="0"/>
+              <a:rPr lang="en-US"/>
               <a:t>: Recall@5, Mean Average Precision</a:t>
             </a:r>
           </a:p>
           <a:p>
             <a:r>
-              <a:rPr lang="en-US" u="sng" dirty="0"/>
+              <a:rPr lang="en-US" u="sng"/>
               <a:t>Verification</a:t>
             </a:r>
             <a:r>
-              <a:rPr lang="en-US" dirty="0"/>
+              <a:rPr lang="en-US"/>
               <a:t>: Macro-F1 (balance of Precision and Recall), </a:t>
             </a:r>
             <a:br>
-              <a:rPr lang="en-US" dirty="0"/>
+              <a:rPr lang="en-US"/>
             </a:br>
             <a:r>
-              <a:rPr lang="en-US" dirty="0"/>
+              <a:rPr lang="en-US"/>
               <a:t>Strict-Macro-F1</a:t>
             </a:r>
-            <a:endParaRPr lang="en-AT" dirty="0"/>
+            <a:endParaRPr lang="en-AT"/>
           </a:p>
         </p:txBody>
       </p:sp>
@@ -6096,16 +7397,16 @@
           <a:lstStyle/>
           <a:p>
             <a:r>
-              <a:rPr lang="en-US" dirty="0"/>
+              <a:rPr lang="en-US"/>
               <a:t>Leaderboard – Retrieval (English)</a:t>
             </a:r>
-            <a:endParaRPr lang="en-AT" dirty="0"/>
+            <a:endParaRPr lang="en-AT"/>
           </a:p>
         </p:txBody>
       </p:sp>
       <p:pic>
         <p:nvPicPr>
-          <p:cNvPr id="12" name="Grafik 11">
+          <p:cNvPr id="12" name="Grafik 11" descr="leaderboard results for retrieval">
             <a:extLst>
               <a:ext uri="{FF2B5EF4-FFF2-40B4-BE49-F238E27FC236}">
                 <a16:creationId xmlns:a16="http://schemas.microsoft.com/office/drawing/2014/main" id="{04E770AC-4188-4890-599A-669EB8E0FAB1}"/>
@@ -6118,7 +7419,7 @@
           <p:nvPr/>
         </p:nvPicPr>
         <p:blipFill>
-          <a:blip r:embed="rId2"/>
+          <a:blip r:embed="rId3"/>
           <a:stretch>
             <a:fillRect/>
           </a:stretch>
@@ -6214,16 +7515,16 @@
           <a:lstStyle/>
           <a:p>
             <a:r>
-              <a:rPr lang="en-US" dirty="0"/>
+              <a:rPr lang="en-US"/>
               <a:t>Leaderboard – Verification (English)</a:t>
             </a:r>
-            <a:endParaRPr lang="en-AT" dirty="0"/>
+            <a:endParaRPr lang="en-AT"/>
           </a:p>
         </p:txBody>
       </p:sp>
       <p:pic>
         <p:nvPicPr>
-          <p:cNvPr id="5" name="Inhaltsplatzhalter 4">
+          <p:cNvPr id="5" name="Inhaltsplatzhalter 4" descr="leaderboard results for verification">
             <a:extLst>
               <a:ext uri="{FF2B5EF4-FFF2-40B4-BE49-F238E27FC236}">
                 <a16:creationId xmlns:a16="http://schemas.microsoft.com/office/drawing/2014/main" id="{55B49F26-860E-E490-7367-11B5F02043F5}"/>
@@ -6238,7 +7539,7 @@
           </p:nvPr>
         </p:nvPicPr>
         <p:blipFill>
-          <a:blip r:embed="rId2"/>
+          <a:blip r:embed="rId3"/>
           <a:stretch>
             <a:fillRect/>
           </a:stretch>
@@ -6331,10 +7632,10 @@
           <a:lstStyle/>
           <a:p>
             <a:r>
-              <a:rPr lang="en-US" dirty="0"/>
+              <a:rPr lang="en-US"/>
               <a:t>Key Findings – Retrieval Stage</a:t>
             </a:r>
-            <a:endParaRPr lang="en-AT" dirty="0"/>
+            <a:endParaRPr lang="en-AT"/>
           </a:p>
         </p:txBody>
       </p:sp>
@@ -6362,31 +7663,31 @@
           <a:lstStyle/>
           <a:p>
             <a:r>
-              <a:rPr lang="en-US" dirty="0"/>
+              <a:rPr lang="en-US"/>
               <a:t>Best* performance via the Terrier implementation of PL2 with some stemming, etc. (divergence-from-randomness lexical method)</a:t>
             </a:r>
           </a:p>
           <a:p>
             <a:pPr lvl="1"/>
             <a:r>
-              <a:rPr lang="en-US" dirty="0"/>
+              <a:rPr lang="en-US"/>
               <a:t>*at the time of submission</a:t>
             </a:r>
           </a:p>
           <a:p>
             <a:r>
-              <a:rPr lang="en-US" dirty="0"/>
+              <a:rPr lang="en-US"/>
               <a:t>On average, using Terrier over OpenAI embeddings and cosine similarity yielded a Macro-F1 improvement of +0.0239</a:t>
             </a:r>
           </a:p>
           <a:p>
             <a:r>
-              <a:rPr lang="en-US" dirty="0"/>
+              <a:rPr lang="en-US"/>
               <a:t>However, the performance gap is small – on the leaderboard, OpenAI embeddings were our best performing retriever method</a:t>
             </a:r>
           </a:p>
           <a:p>
-            <a:endParaRPr lang="en-US" dirty="0"/>
+            <a:endParaRPr lang="en-US"/>
           </a:p>
         </p:txBody>
       </p:sp>
@@ -6471,10 +7772,10 @@
           <a:lstStyle/>
           <a:p>
             <a:r>
-              <a:rPr lang="en-US" dirty="0"/>
+              <a:rPr lang="en-US"/>
               <a:t>Key Findings – Verification Stage</a:t>
             </a:r>
-            <a:endParaRPr lang="en-AT" dirty="0"/>
+            <a:endParaRPr lang="en-AT"/>
           </a:p>
         </p:txBody>
       </p:sp>
@@ -6525,15 +7826,14 @@
           <a:p>
             <a:r>
               <a:rPr lang="en-US" dirty="0"/>
-              <a:t>BERT variants fine-tuned on NLI datasets did not generalize well to this task</a:t>
-            </a:r>
-          </a:p>
-          <a:p>
-            <a:r>
-              <a:rPr lang="en-US" dirty="0"/>
-              <a:t>GPT-4-Turbo was much more reliable &amp; performant than Llama3-70b (expected outcome)</a:t>
-            </a:r>
-            <a:endParaRPr lang="en-AT" dirty="0"/>
+              <a:t>BERT variants fine-tuned on NLI datasets did not generalize well to this task, but GPT-4-Turbo was much more reliable &amp; performant than Llama3-70b (expected outcome)</a:t>
+            </a:r>
+          </a:p>
+          <a:p>
+            <a:r>
+              <a:rPr lang="en-GB" dirty="0"/>
+              <a:t>Retrieval only needs to be „good enough“ (for this dataset)</a:t>
+            </a:r>
           </a:p>
         </p:txBody>
       </p:sp>
@@ -6618,10 +7918,10 @@
           <a:lstStyle/>
           <a:p>
             <a:r>
-              <a:rPr lang="en-US" dirty="0"/>
+              <a:rPr lang="en-US"/>
               <a:t>Key Findings – Features</a:t>
             </a:r>
-            <a:endParaRPr lang="en-AT" dirty="0"/>
+            <a:endParaRPr lang="en-AT"/>
           </a:p>
         </p:txBody>
       </p:sp>
@@ -6647,49 +7947,49 @@
           <a:lstStyle/>
           <a:p>
             <a:r>
-              <a:rPr lang="en-US" dirty="0"/>
+              <a:rPr lang="en-US"/>
               <a:t>In our experiments, the best settings were:</a:t>
             </a:r>
           </a:p>
           <a:p>
             <a:pPr lvl="1"/>
             <a:r>
-              <a:rPr lang="en-US" u="sng" dirty="0"/>
+              <a:rPr lang="en-US" u="sng"/>
               <a:t>NO preprocessing</a:t>
             </a:r>
             <a:r>
-              <a:rPr lang="en-US" dirty="0"/>
+              <a:rPr lang="en-US"/>
               <a:t> done to claim and evidence</a:t>
             </a:r>
           </a:p>
           <a:p>
             <a:pPr lvl="1"/>
             <a:r>
-              <a:rPr lang="en-US" u="sng" dirty="0"/>
+              <a:rPr lang="en-US" u="sng"/>
               <a:t>NO additional author data</a:t>
             </a:r>
             <a:r>
-              <a:rPr lang="en-US" dirty="0"/>
+              <a:rPr lang="en-US"/>
               <a:t> added to the evidence (display-name &amp; bio)</a:t>
             </a:r>
           </a:p>
           <a:p>
             <a:pPr lvl="1"/>
             <a:r>
-              <a:rPr lang="en-US" dirty="0"/>
+              <a:rPr lang="en-US"/>
               <a:t>Giving a lot of weight to each piece of evidence was beneficial</a:t>
             </a:r>
           </a:p>
           <a:p>
             <a:pPr lvl="2"/>
             <a:r>
-              <a:rPr lang="en-US" dirty="0"/>
+              <a:rPr lang="en-US"/>
               <a:t>(ignoring individual “NOT ENOUGH INFO” claim-evidence pairings in the overall rumor labelling decision, as the evidence was likely unrelated to the claim, and we always pass 5 pairings to the verification stage)</a:t>
             </a:r>
           </a:p>
           <a:p>
             <a:pPr lvl="1"/>
-            <a:endParaRPr lang="en-US" dirty="0"/>
+            <a:endParaRPr lang="en-US"/>
           </a:p>
         </p:txBody>
       </p:sp>
@@ -6738,6 +8038,16 @@
 <file path=ppt/slides/slide18.xml><?xml version="1.0" encoding="utf-8"?>
 <p:sld xmlns:a="http://schemas.openxmlformats.org/drawingml/2006/main" xmlns:r="http://schemas.openxmlformats.org/officeDocument/2006/relationships" xmlns:p="http://schemas.openxmlformats.org/presentationml/2006/main">
   <p:cSld>
+    <p:bg>
+      <p:bgPr>
+        <a:solidFill>
+          <a:schemeClr val="accent3">
+            <a:lumMod val="75000"/>
+          </a:schemeClr>
+        </a:solidFill>
+        <a:effectLst/>
+      </p:bgPr>
+    </p:bg>
     <p:spTree>
       <p:nvGrpSpPr>
         <p:cNvPr id="1" name=""/>
@@ -6774,10 +8084,10 @@
           <a:lstStyle/>
           <a:p>
             <a:r>
-              <a:rPr lang="en-US" dirty="0"/>
+              <a:rPr lang="en-US"/>
               <a:t>Findings since Submission Deadline (1/2)</a:t>
             </a:r>
-            <a:endParaRPr lang="en-AT" dirty="0"/>
+            <a:endParaRPr lang="en-AT"/>
           </a:p>
         </p:txBody>
       </p:sp>
@@ -6878,7 +8188,7 @@
     </p:extLst>
   </p:cSld>
   <p:clrMapOvr>
-    <a:masterClrMapping/>
+    <a:overrideClrMapping bg1="dk1" tx1="lt1" bg2="dk2" tx2="lt2" accent1="accent1" accent2="accent2" accent3="accent3" accent4="accent4" accent5="accent5" accent6="accent6" hlink="hlink" folHlink="folHlink"/>
   </p:clrMapOvr>
 </p:sld>
 </file>
@@ -6886,6 +8196,16 @@
 <file path=ppt/slides/slide19.xml><?xml version="1.0" encoding="utf-8"?>
 <p:sld xmlns:a="http://schemas.openxmlformats.org/drawingml/2006/main" xmlns:r="http://schemas.openxmlformats.org/officeDocument/2006/relationships" xmlns:p="http://schemas.openxmlformats.org/presentationml/2006/main">
   <p:cSld>
+    <p:bg>
+      <p:bgPr>
+        <a:solidFill>
+          <a:schemeClr val="accent3">
+            <a:lumMod val="75000"/>
+          </a:schemeClr>
+        </a:solidFill>
+        <a:effectLst/>
+      </p:bgPr>
+    </p:bg>
     <p:spTree>
       <p:nvGrpSpPr>
         <p:cNvPr id="1" name=""/>
@@ -6922,10 +8242,10 @@
           <a:lstStyle/>
           <a:p>
             <a:r>
-              <a:rPr lang="en-US" dirty="0"/>
+              <a:rPr lang="en-US"/>
               <a:t>Findings since Submission Deadline (2/2)</a:t>
             </a:r>
-            <a:endParaRPr lang="en-AT" dirty="0"/>
+            <a:endParaRPr lang="en-AT"/>
           </a:p>
         </p:txBody>
       </p:sp>
@@ -6968,22 +8288,39 @@
               <a:buChar char="•"/>
             </a:pPr>
             <a:r>
-              <a:rPr lang="en-US" sz="2600" kern="1200" dirty="0">
-                <a:solidFill>
-                  <a:srgbClr val="FFFFFF">
-                    <a:alpha val="70000"/>
-                  </a:srgbClr>
-                </a:solidFill>
-                <a:effectLst/>
-                <a:latin typeface="Bahnschrift" panose="020B0502040204020203" pitchFamily="34" charset="0"/>
-                <a:ea typeface="+mn-ea"/>
-                <a:cs typeface="+mn-cs"/>
-              </a:rPr>
-              <a:t>The “weight class” of GPT-4o class of models is a good balance of capability &amp; cost (a bit better than Llama-3.1-70b)</a:t>
-            </a:r>
-            <a:endParaRPr lang="en-AT" sz="2600" dirty="0">
-              <a:effectLst/>
-            </a:endParaRPr>
+              <a:rPr lang="en-US" sz="2600" dirty="0"/>
+              <a:t>The “weight class” of GPT-4o class of models is a good balance of capability &amp; cost (a bit better than Llama-3.1 variants)</a:t>
+            </a:r>
+            <a:endParaRPr lang="en-AT" sz="2600" dirty="0"/>
+          </a:p>
+        </p:txBody>
+      </p:sp>
+      <p:sp>
+        <p:nvSpPr>
+          <p:cNvPr id="4" name="Foliennummernplatzhalter 3">
+            <a:extLst>
+              <a:ext uri="{FF2B5EF4-FFF2-40B4-BE49-F238E27FC236}">
+                <a16:creationId xmlns:a16="http://schemas.microsoft.com/office/drawing/2014/main" id="{FDD4F62A-C719-1DC7-6644-FA52B7626E76}"/>
+              </a:ext>
+            </a:extLst>
+          </p:cNvPr>
+          <p:cNvSpPr>
+            <a:spLocks noGrp="1"/>
+          </p:cNvSpPr>
+          <p:nvPr>
+            <p:ph type="sldNum" sz="quarter" idx="12"/>
+          </p:nvPr>
+        </p:nvSpPr>
+        <p:spPr/>
+        <p:txBody>
+          <a:bodyPr/>
+          <a:lstStyle/>
+          <a:p>
+            <a:fld id="{07CE569E-9B7C-4CB9-AB80-C0841F922CFF}" type="slidenum">
+              <a:rPr lang="en-US" smtClean="0"/>
+              <a:t>19</a:t>
+            </a:fld>
+            <a:endParaRPr lang="en-US"/>
           </a:p>
         </p:txBody>
       </p:sp>
@@ -7001,7 +8338,7 @@
         </p:nvSpPr>
         <p:spPr>
           <a:xfrm>
-            <a:off x="7437747" y="3943350"/>
+            <a:off x="8017984" y="3932464"/>
             <a:ext cx="3992253" cy="1692771"/>
           </a:xfrm>
           <a:prstGeom prst="rect">
@@ -7016,65 +8353,42 @@
           <a:lstStyle/>
           <a:p>
             <a:r>
-              <a:rPr lang="en-US" sz="2600">
-                <a:solidFill>
-                  <a:srgbClr val="FFFFFF">
-                    <a:alpha val="70000"/>
-                  </a:srgbClr>
-                </a:solidFill>
-                <a:latin typeface="Bahnschrift" panose="020B0502040204020203" pitchFamily="34" charset="0"/>
-              </a:rPr>
-              <a:t>Verification experiment results </a:t>
-            </a:r>
-            <a:r>
               <a:rPr lang="en-US" sz="2600" dirty="0">
                 <a:solidFill>
-                  <a:srgbClr val="FFFFFF">
-                    <a:alpha val="70000"/>
-                  </a:srgbClr>
+                  <a:srgbClr val="FFFFFF"/>
                 </a:solidFill>
-                <a:latin typeface="Bahnschrift" panose="020B0502040204020203" pitchFamily="34" charset="0"/>
               </a:rPr>
-              <a:t>on the </a:t>
+              <a:t>Verification experiment results on the </a:t>
             </a:r>
             <a:br>
               <a:rPr lang="en-US" sz="2600" dirty="0">
                 <a:solidFill>
-                  <a:srgbClr val="FFFFFF">
-                    <a:alpha val="70000"/>
-                  </a:srgbClr>
+                  <a:srgbClr val="FFFFFF"/>
                 </a:solidFill>
-                <a:latin typeface="Bahnschrift" panose="020B0502040204020203" pitchFamily="34" charset="0"/>
               </a:rPr>
             </a:br>
             <a:r>
               <a:rPr lang="en-US" sz="2600" dirty="0">
                 <a:solidFill>
-                  <a:srgbClr val="FFFFFF">
-                    <a:alpha val="70000"/>
-                  </a:srgbClr>
+                  <a:srgbClr val="FFFFFF"/>
                 </a:solidFill>
-                <a:latin typeface="Bahnschrift" panose="020B0502040204020203" pitchFamily="34" charset="0"/>
               </a:rPr>
               <a:t>combined (train &amp; dev) dataset</a:t>
             </a:r>
             <a:endParaRPr lang="en-AT" sz="2600" dirty="0">
               <a:solidFill>
-                <a:srgbClr val="FFFFFF">
-                  <a:alpha val="70000"/>
-                </a:srgbClr>
+                <a:srgbClr val="FFFFFF"/>
               </a:solidFill>
-              <a:latin typeface="Bahnschrift" panose="020B0502040204020203" pitchFamily="34" charset="0"/>
             </a:endParaRPr>
           </a:p>
         </p:txBody>
       </p:sp>
       <p:pic>
         <p:nvPicPr>
-          <p:cNvPr id="9" name="Grafik 8">
-            <a:extLst>
-              <a:ext uri="{FF2B5EF4-FFF2-40B4-BE49-F238E27FC236}">
-                <a16:creationId xmlns:a16="http://schemas.microsoft.com/office/drawing/2014/main" id="{A477A834-0BE2-BC9F-042C-DDBA95026CB0}"/>
+          <p:cNvPr id="10" name="Grafik 9">
+            <a:extLst>
+              <a:ext uri="{FF2B5EF4-FFF2-40B4-BE49-F238E27FC236}">
+                <a16:creationId xmlns:a16="http://schemas.microsoft.com/office/drawing/2014/main" id="{082BD47B-12A3-7F9F-C63A-9130178F78DD}"/>
               </a:ext>
             </a:extLst>
           </p:cNvPr>
@@ -7084,50 +8398,21 @@
           <p:nvPr/>
         </p:nvPicPr>
         <p:blipFill>
-          <a:blip r:embed="rId3"/>
+          <a:blip r:embed="rId4"/>
           <a:stretch>
             <a:fillRect/>
           </a:stretch>
         </p:blipFill>
         <p:spPr>
           <a:xfrm>
-            <a:off x="124256" y="3725853"/>
-            <a:ext cx="7192379" cy="2724530"/>
+            <a:off x="187929" y="3477731"/>
+            <a:ext cx="7592485" cy="3067478"/>
           </a:xfrm>
           <a:prstGeom prst="rect">
             <a:avLst/>
           </a:prstGeom>
         </p:spPr>
       </p:pic>
-      <p:sp>
-        <p:nvSpPr>
-          <p:cNvPr id="4" name="Foliennummernplatzhalter 3">
-            <a:extLst>
-              <a:ext uri="{FF2B5EF4-FFF2-40B4-BE49-F238E27FC236}">
-                <a16:creationId xmlns:a16="http://schemas.microsoft.com/office/drawing/2014/main" id="{FDD4F62A-C719-1DC7-6644-FA52B7626E76}"/>
-              </a:ext>
-            </a:extLst>
-          </p:cNvPr>
-          <p:cNvSpPr>
-            <a:spLocks noGrp="1"/>
-          </p:cNvSpPr>
-          <p:nvPr>
-            <p:ph type="sldNum" sz="quarter" idx="12"/>
-          </p:nvPr>
-        </p:nvSpPr>
-        <p:spPr/>
-        <p:txBody>
-          <a:bodyPr/>
-          <a:lstStyle/>
-          <a:p>
-            <a:fld id="{07CE569E-9B7C-4CB9-AB80-C0841F922CFF}" type="slidenum">
-              <a:rPr lang="en-US" smtClean="0"/>
-              <a:t>19</a:t>
-            </a:fld>
-            <a:endParaRPr lang="en-US"/>
-          </a:p>
-        </p:txBody>
-      </p:sp>
     </p:spTree>
     <p:extLst>
       <p:ext uri="{BB962C8B-B14F-4D97-AF65-F5344CB8AC3E}">
@@ -7136,7 +8421,7 @@
     </p:extLst>
   </p:cSld>
   <p:clrMapOvr>
-    <a:masterClrMapping/>
+    <a:overrideClrMapping bg1="dk1" tx1="lt1" bg2="dk2" tx2="lt2" accent1="accent1" accent2="accent2" accent3="accent3" accent4="accent4" accent5="accent5" accent6="accent6" hlink="hlink" folHlink="folHlink"/>
   </p:clrMapOvr>
 </p:sld>
 </file>
@@ -7180,10 +8465,10 @@
           <a:lstStyle/>
           <a:p>
             <a:r>
-              <a:rPr lang="en-US" dirty="0"/>
+              <a:rPr lang="en-US"/>
               <a:t>Briefly, an Overview</a:t>
             </a:r>
-            <a:endParaRPr lang="de-DE" dirty="0"/>
+            <a:endParaRPr lang="de-DE"/>
           </a:p>
         </p:txBody>
       </p:sp>
@@ -7211,37 +8496,37 @@
           <a:lstStyle/>
           <a:p>
             <a:r>
-              <a:rPr lang="en-US" dirty="0"/>
+              <a:rPr lang="en-US"/>
               <a:t>We already heard about the task – what was our approach?</a:t>
             </a:r>
           </a:p>
           <a:p>
             <a:r>
-              <a:rPr lang="en-US" dirty="0"/>
+              <a:rPr lang="en-US"/>
               <a:t>Experiment with Retrieval Approaches</a:t>
             </a:r>
           </a:p>
           <a:p>
             <a:r>
-              <a:rPr lang="en-US" dirty="0"/>
+              <a:rPr lang="en-US"/>
               <a:t>See if LLMs hold any promise for Verification</a:t>
             </a:r>
           </a:p>
           <a:p>
             <a:r>
-              <a:rPr lang="en-US" dirty="0"/>
+              <a:rPr lang="en-US"/>
               <a:t>Experiment with NLP Methods for Retrieval &amp; Verification</a:t>
             </a:r>
           </a:p>
           <a:p>
             <a:r>
-              <a:rPr lang="en-US" dirty="0"/>
+              <a:rPr lang="en-US"/>
               <a:t>We don’t train a model, but approach this in a zero-shot fashion</a:t>
             </a:r>
           </a:p>
           <a:p>
             <a:r>
-              <a:rPr lang="en-US" dirty="0"/>
+              <a:rPr lang="en-US"/>
               <a:t>“Authority” != Government Account (possible, but not necessary)</a:t>
             </a:r>
           </a:p>
@@ -7328,10 +8613,10 @@
           <a:lstStyle/>
           <a:p>
             <a:r>
-              <a:rPr lang="en-US" dirty="0"/>
+              <a:rPr lang="en-US"/>
               <a:t>Caveats &amp; Discussion</a:t>
             </a:r>
-            <a:endParaRPr lang="en-AT" dirty="0"/>
+            <a:endParaRPr lang="en-AT"/>
           </a:p>
         </p:txBody>
       </p:sp>
@@ -7359,59 +8644,59 @@
           <a:lstStyle/>
           <a:p>
             <a:r>
-              <a:rPr lang="en-US" dirty="0"/>
+              <a:rPr lang="en-US"/>
               <a:t>LLMs-as-a-Service are subject to </a:t>
             </a:r>
             <a:r>
-              <a:rPr lang="en-US" u="sng" dirty="0"/>
+              <a:rPr lang="en-US" u="sng"/>
               <a:t>proprietary moderation</a:t>
             </a:r>
             <a:r>
-              <a:rPr lang="en-US" dirty="0"/>
+              <a:rPr lang="en-US"/>
               <a:t> (and sensitive topics are to be expected when dealing with rumors)</a:t>
             </a:r>
           </a:p>
           <a:p>
             <a:pPr lvl="1"/>
             <a:r>
-              <a:rPr lang="en-US" dirty="0"/>
+              <a:rPr lang="en-US"/>
               <a:t>Ideally, you would use your own models, and fine-tune them continually on real data</a:t>
             </a:r>
           </a:p>
           <a:p>
             <a:r>
-              <a:rPr lang="en-US" u="sng" dirty="0"/>
+              <a:rPr lang="en-US" u="sng"/>
               <a:t>Scalability</a:t>
             </a:r>
             <a:r>
-              <a:rPr lang="en-US" dirty="0"/>
+              <a:rPr lang="en-US"/>
               <a:t> would require trade-offs</a:t>
             </a:r>
           </a:p>
           <a:p>
             <a:r>
-              <a:rPr lang="en-US" dirty="0"/>
+              <a:rPr lang="en-US"/>
               <a:t>This Lab task did not cover </a:t>
             </a:r>
             <a:r>
-              <a:rPr lang="en-US" u="sng" dirty="0"/>
+              <a:rPr lang="en-US" u="sng"/>
               <a:t>finding the authority account timelines</a:t>
             </a:r>
             <a:r>
-              <a:rPr lang="en-US" dirty="0"/>
+              <a:rPr lang="en-US"/>
               <a:t> our system relies on – this is an entirely separate task</a:t>
             </a:r>
           </a:p>
           <a:p>
             <a:r>
-              <a:rPr lang="en-US" u="sng" dirty="0"/>
+              <a:rPr lang="en-US" u="sng"/>
               <a:t>Multimodality</a:t>
             </a:r>
             <a:r>
-              <a:rPr lang="en-US" dirty="0"/>
+              <a:rPr lang="en-US"/>
               <a:t> – we did not use images &amp; video content in our approach, though this could be integrated given the multimodal models today</a:t>
             </a:r>
-            <a:endParaRPr lang="en-AT" dirty="0"/>
+            <a:endParaRPr lang="en-AT"/>
           </a:p>
         </p:txBody>
       </p:sp>
@@ -7496,10 +8781,10 @@
           <a:lstStyle/>
           <a:p>
             <a:r>
-              <a:rPr lang="en-US" dirty="0"/>
+              <a:rPr lang="en-US"/>
               <a:t>Potential for Future Work</a:t>
             </a:r>
-            <a:endParaRPr lang="en-AT" dirty="0"/>
+            <a:endParaRPr lang="en-AT"/>
           </a:p>
         </p:txBody>
       </p:sp>
@@ -7527,36 +8812,36 @@
           <a:lstStyle/>
           <a:p>
             <a:r>
-              <a:rPr lang="en-US" dirty="0"/>
+              <a:rPr lang="en-US"/>
               <a:t>Multimodality</a:t>
             </a:r>
           </a:p>
           <a:p>
             <a:r>
-              <a:rPr lang="en-US" dirty="0"/>
+              <a:rPr lang="en-US"/>
               <a:t>Multilingualism</a:t>
             </a:r>
           </a:p>
           <a:p>
             <a:r>
-              <a:rPr lang="en-US" dirty="0"/>
+              <a:rPr lang="en-US"/>
               <a:t>Integration of more “meta-data” (for example: social graph, or interactions between claim and evidence – was the evidence a response/quote-tweet, or none of these?)</a:t>
             </a:r>
           </a:p>
           <a:p>
             <a:r>
-              <a:rPr lang="en-US" dirty="0"/>
+              <a:rPr lang="en-US"/>
               <a:t>If we’re already using LLMs – </a:t>
             </a:r>
             <a:r>
-              <a:rPr lang="en-US" u="sng" dirty="0"/>
+              <a:rPr lang="en-US" u="sng"/>
               <a:t>explainability</a:t>
             </a:r>
             <a:r>
-              <a:rPr lang="en-US" dirty="0"/>
+              <a:rPr lang="en-US"/>
               <a:t>! (via generation of “justifications”) </a:t>
             </a:r>
-            <a:endParaRPr lang="en-AT" dirty="0"/>
+            <a:endParaRPr lang="en-AT"/>
           </a:p>
         </p:txBody>
       </p:sp>
@@ -7641,10 +8926,10 @@
           <a:lstStyle/>
           <a:p>
             <a:r>
-              <a:rPr lang="en-US" dirty="0"/>
+              <a:rPr lang="en-US"/>
               <a:t>Conclusion</a:t>
             </a:r>
-            <a:endParaRPr lang="en-AT" dirty="0"/>
+            <a:endParaRPr lang="en-AT"/>
           </a:p>
         </p:txBody>
       </p:sp>
@@ -7670,29 +8955,29 @@
           <a:lstStyle/>
           <a:p>
             <a:r>
-              <a:rPr lang="en-US" dirty="0"/>
+              <a:rPr lang="en-US"/>
               <a:t>We submitted the best performing system to the</a:t>
             </a:r>
             <a:br>
-              <a:rPr lang="en-US" dirty="0"/>
+              <a:rPr lang="en-US"/>
             </a:br>
             <a:r>
-              <a:rPr lang="en-US" dirty="0"/>
+              <a:rPr lang="en-US"/>
               <a:t>CheckThat! Lab Task 5 (English)</a:t>
             </a:r>
           </a:p>
           <a:p>
             <a:r>
-              <a:rPr lang="en-US" dirty="0"/>
+              <a:rPr lang="en-US"/>
               <a:t>LLMs can work as powerful language inference agents</a:t>
             </a:r>
           </a:p>
           <a:p>
             <a:r>
-              <a:rPr lang="en-US" dirty="0"/>
+              <a:rPr lang="en-US"/>
               <a:t>There is already plenty of distrust in AI (especially LLMs) today! Science communication is important to build trust in systems like this</a:t>
             </a:r>
-            <a:endParaRPr lang="en-AT" dirty="0"/>
+            <a:endParaRPr lang="en-AT"/>
           </a:p>
         </p:txBody>
       </p:sp>
@@ -7773,8 +9058,8 @@
         </p:nvSpPr>
         <p:spPr>
           <a:xfrm>
-            <a:off x="2006258" y="761999"/>
-            <a:ext cx="10668000" cy="1524000"/>
+            <a:off x="2695300" y="761999"/>
+            <a:ext cx="9289915" cy="1524000"/>
           </a:xfrm>
         </p:spPr>
         <p:txBody>
@@ -7831,6 +9116,48 @@
       </p:pic>
       <p:sp>
         <p:nvSpPr>
+          <p:cNvPr id="5" name="Textfeld 4">
+            <a:extLst>
+              <a:ext uri="{FF2B5EF4-FFF2-40B4-BE49-F238E27FC236}">
+                <a16:creationId xmlns:a16="http://schemas.microsoft.com/office/drawing/2014/main" id="{8C8F5E0A-6B9B-82B4-E73A-5E5EFA11E80A}"/>
+              </a:ext>
+            </a:extLst>
+          </p:cNvPr>
+          <p:cNvSpPr txBox="1"/>
+          <p:nvPr/>
+        </p:nvSpPr>
+        <p:spPr>
+          <a:xfrm>
+            <a:off x="4463999" y="4653617"/>
+            <a:ext cx="6449201" cy="523220"/>
+          </a:xfrm>
+          <a:prstGeom prst="rect">
+            <a:avLst/>
+          </a:prstGeom>
+          <a:noFill/>
+        </p:spPr>
+        <p:txBody>
+          <a:bodyPr wrap="square" rtlCol="0">
+            <a:spAutoFit/>
+          </a:bodyPr>
+          <a:lstStyle/>
+          <a:p>
+            <a:r>
+              <a:rPr lang="en-US" sz="2800" dirty="0"/>
+              <a:t>Retrieve my Contact Info at </a:t>
+            </a:r>
+            <a:r>
+              <a:rPr lang="en-US" sz="2800" dirty="0">
+                <a:hlinkClick r:id="rId4"/>
+              </a:rPr>
+              <a:t>luiskolb.at</a:t>
+            </a:r>
+            <a:endParaRPr lang="en-US" sz="2800" dirty="0"/>
+          </a:p>
+        </p:txBody>
+      </p:sp>
+      <p:sp>
+        <p:nvSpPr>
           <p:cNvPr id="4" name="Textfeld 3">
             <a:extLst>
               <a:ext uri="{FF2B5EF4-FFF2-40B4-BE49-F238E27FC236}">
@@ -7859,53 +9186,8 @@
           <a:p>
             <a:pPr algn="ctr"/>
             <a:r>
-              <a:rPr lang="en-US" sz="2800" dirty="0"/>
+              <a:rPr lang="en-US" sz="2800"/>
               <a:t>Slides on GitHub ⬇️</a:t>
-            </a:r>
-          </a:p>
-        </p:txBody>
-      </p:sp>
-      <p:sp>
-        <p:nvSpPr>
-          <p:cNvPr id="5" name="Textfeld 4">
-            <a:extLst>
-              <a:ext uri="{FF2B5EF4-FFF2-40B4-BE49-F238E27FC236}">
-                <a16:creationId xmlns:a16="http://schemas.microsoft.com/office/drawing/2014/main" id="{8C8F5E0A-6B9B-82B4-E73A-5E5EFA11E80A}"/>
-              </a:ext>
-            </a:extLst>
-          </p:cNvPr>
-          <p:cNvSpPr txBox="1"/>
-          <p:nvPr/>
-        </p:nvSpPr>
-        <p:spPr>
-          <a:xfrm>
-            <a:off x="5312788" y="4915227"/>
-            <a:ext cx="4445448" cy="523220"/>
-          </a:xfrm>
-          <a:prstGeom prst="rect">
-            <a:avLst/>
-          </a:prstGeom>
-          <a:noFill/>
-        </p:spPr>
-        <p:txBody>
-          <a:bodyPr wrap="none" rtlCol="0">
-            <a:spAutoFit/>
-          </a:bodyPr>
-          <a:lstStyle/>
-          <a:p>
-            <a:r>
-              <a:rPr lang="en-US" sz="2800" dirty="0"/>
-              <a:t>Contact Info at </a:t>
-            </a:r>
-            <a:r>
-              <a:rPr lang="en-US" sz="2800" dirty="0">
-                <a:hlinkClick r:id="rId4"/>
-              </a:rPr>
-              <a:t>luiskolb.at</a:t>
-            </a:r>
-            <a:r>
-              <a:rPr lang="en-US" sz="2800" dirty="0"/>
-              <a:t>  </a:t>
             </a:r>
           </a:p>
         </p:txBody>
@@ -7963,6 +9245,9 @@
             <a:extLst>
               <a:ext uri="{FF2B5EF4-FFF2-40B4-BE49-F238E27FC236}">
                 <a16:creationId xmlns:a16="http://schemas.microsoft.com/office/drawing/2014/main" id="{53E7D928-EE99-E631-C428-5F75374632CB}"/>
+              </a:ext>
+              <a:ext uri="{C183D7F6-B498-43B3-948B-1728B52AA6E4}">
+                <adec:decorative xmlns:adec="http://schemas.microsoft.com/office/drawing/2017/decorative" val="0"/>
               </a:ext>
             </a:extLst>
           </p:cNvPr>
@@ -8043,16 +9328,16 @@
           <a:lstStyle/>
           <a:p>
             <a:r>
-              <a:rPr lang="en-US" dirty="0"/>
+              <a:rPr lang="en-US"/>
               <a:t>Our Two-Stage Approach (and task recap)</a:t>
             </a:r>
-            <a:endParaRPr lang="de-DE" dirty="0"/>
+            <a:endParaRPr lang="de-DE"/>
           </a:p>
         </p:txBody>
       </p:sp>
       <p:pic>
         <p:nvPicPr>
-          <p:cNvPr id="6" name="Inhaltsplatzhalter 5" descr="Ein Bild, das Text, Screenshot, Diagramm, Schrift enthält.&#10;&#10;Automatisch generierte Beschreibung">
+          <p:cNvPr id="6" name="Inhaltsplatzhalter 5" descr="approach diagram">
             <a:extLst>
               <a:ext uri="{FF2B5EF4-FFF2-40B4-BE49-F238E27FC236}">
                 <a16:creationId xmlns:a16="http://schemas.microsoft.com/office/drawing/2014/main" id="{D57F5F0E-80EF-004C-AA5C-2A040F362508}"/>
@@ -8171,16 +9456,16 @@
           <a:lstStyle/>
           <a:p>
             <a:r>
-              <a:rPr lang="en-US" dirty="0"/>
-              <a:t>Our Two-Stage Approach (and task recap)</a:t>
-            </a:r>
-            <a:endParaRPr lang="de-DE" dirty="0"/>
+              <a:rPr lang="en-US"/>
+              <a:t>Our Two-Stage Approach</a:t>
+            </a:r>
+            <a:endParaRPr lang="de-DE"/>
           </a:p>
         </p:txBody>
       </p:sp>
       <p:pic>
         <p:nvPicPr>
-          <p:cNvPr id="6" name="Inhaltsplatzhalter 5" descr="Ein Bild, das Text, Screenshot, Diagramm, Schrift enthält.&#10;&#10;Automatisch generierte Beschreibung">
+          <p:cNvPr id="6" name="Inhaltsplatzhalter 5" descr="approach diagram">
             <a:extLst>
               <a:ext uri="{FF2B5EF4-FFF2-40B4-BE49-F238E27FC236}">
                 <a16:creationId xmlns:a16="http://schemas.microsoft.com/office/drawing/2014/main" id="{D57F5F0E-80EF-004C-AA5C-2A040F362508}"/>
@@ -8219,6 +9504,9 @@
             <a:extLst>
               <a:ext uri="{FF2B5EF4-FFF2-40B4-BE49-F238E27FC236}">
                 <a16:creationId xmlns:a16="http://schemas.microsoft.com/office/drawing/2014/main" id="{663296B6-7DF2-9748-2C3E-DDE54E15691C}"/>
+              </a:ext>
+              <a:ext uri="{C183D7F6-B498-43B3-948B-1728B52AA6E4}">
+                <adec:decorative xmlns:adec="http://schemas.microsoft.com/office/drawing/2017/decorative" val="1"/>
               </a:ext>
             </a:extLst>
           </p:cNvPr>
@@ -8274,6 +9562,9 @@
               <a:ext uri="{FF2B5EF4-FFF2-40B4-BE49-F238E27FC236}">
                 <a16:creationId xmlns:a16="http://schemas.microsoft.com/office/drawing/2014/main" id="{DA3A8228-8F7D-FC2A-3BC9-B168AF8A5739}"/>
               </a:ext>
+              <a:ext uri="{C183D7F6-B498-43B3-948B-1728B52AA6E4}">
+                <adec:decorative xmlns:adec="http://schemas.microsoft.com/office/drawing/2017/decorative" val="1"/>
+              </a:ext>
             </a:extLst>
           </p:cNvPr>
           <p:cNvSpPr/>
@@ -8402,7 +9693,7 @@
           <a:lstStyle/>
           <a:p>
             <a:r>
-              <a:rPr lang="en-US" dirty="0"/>
+              <a:rPr lang="en-US"/>
               <a:t>Let‘s look at an example</a:t>
             </a:r>
           </a:p>
@@ -8488,22 +9779,7 @@
             </a:pPr>
             <a:r>
               <a:rPr lang="en-US" dirty="0"/>
-              <a:t>“</a:t>
-            </a:r>
-            <a:r>
-              <a:rPr lang="en-US" dirty="0">
-                <a:solidFill>
-                  <a:schemeClr val="tx1">
-                    <a:lumMod val="95000"/>
-                    <a:alpha val="70000"/>
-                  </a:schemeClr>
-                </a:solidFill>
-              </a:rPr>
-              <a:t>timeline</a:t>
-            </a:r>
-            <a:r>
-              <a:rPr lang="en-US" dirty="0"/>
-              <a:t>": [</a:t>
+              <a:t>“timeline": [</a:t>
             </a:r>
           </a:p>
           <a:p>
@@ -8516,7 +9792,11 @@
             </a:r>
             <a:r>
               <a:rPr lang="en-US" u="sng" dirty="0"/>
-              <a:t>https://twitter.com/LBpresidency</a:t>
+              <a:t>https://twitter.com/</a:t>
+            </a:r>
+            <a:r>
+              <a:rPr lang="en-US" u="sng" dirty="0" err="1"/>
+              <a:t>LBpresidency</a:t>
             </a:r>
             <a:r>
               <a:rPr lang="en-US" dirty="0"/>
@@ -8631,8 +9911,8 @@
           <a:lstStyle/>
           <a:p>
             <a:r>
-              <a:rPr lang="en-US" dirty="0"/>
-              <a:t>Let‘s look at an example</a:t>
+              <a:rPr lang="en-US"/>
+              <a:t>Let‘s look at an example </a:t>
             </a:r>
           </a:p>
         </p:txBody>
@@ -8717,22 +9997,7 @@
             </a:pPr>
             <a:r>
               <a:rPr lang="en-US" dirty="0"/>
-              <a:t>"</a:t>
-            </a:r>
-            <a:r>
-              <a:rPr lang="en-US" dirty="0">
-                <a:solidFill>
-                  <a:schemeClr val="tx1">
-                    <a:lumMod val="95000"/>
-                    <a:alpha val="70000"/>
-                  </a:schemeClr>
-                </a:solidFill>
-              </a:rPr>
-              <a:t>timeline</a:t>
-            </a:r>
-            <a:r>
-              <a:rPr lang="en-US" dirty="0"/>
-              <a:t>": [</a:t>
+              <a:t>"timeline": [</a:t>
             </a:r>
           </a:p>
           <a:p>
@@ -8749,7 +10014,15 @@
                   <a:srgbClr val="FF0000"/>
                 </a:highlight>
               </a:rPr>
-              <a:t>https://twitter.com/LBpresidency</a:t>
+              <a:t>https://twitter.com/</a:t>
+            </a:r>
+            <a:r>
+              <a:rPr lang="en-US" u="sng" dirty="0" err="1">
+                <a:highlight>
+                  <a:srgbClr val="FF0000"/>
+                </a:highlight>
+              </a:rPr>
+              <a:t>LBpresidency</a:t>
             </a:r>
             <a:r>
               <a:rPr lang="en-US" dirty="0"/>
@@ -8869,16 +10142,16 @@
           <a:lstStyle/>
           <a:p>
             <a:r>
-              <a:rPr lang="en-US" dirty="0"/>
+              <a:rPr lang="en-US"/>
               <a:t>Our Two-Stage Approach</a:t>
             </a:r>
-            <a:endParaRPr lang="de-DE" dirty="0"/>
+            <a:endParaRPr lang="de-DE"/>
           </a:p>
         </p:txBody>
       </p:sp>
       <p:pic>
         <p:nvPicPr>
-          <p:cNvPr id="6" name="Inhaltsplatzhalter 5" descr="Ein Bild, das Text, Screenshot, Diagramm, Schrift enthält.&#10;&#10;Automatisch generierte Beschreibung">
+          <p:cNvPr id="6" name="Inhaltsplatzhalter 5" descr="approach diagram">
             <a:extLst>
               <a:ext uri="{FF2B5EF4-FFF2-40B4-BE49-F238E27FC236}">
                 <a16:creationId xmlns:a16="http://schemas.microsoft.com/office/drawing/2014/main" id="{D57F5F0E-80EF-004C-AA5C-2A040F362508}"/>
@@ -8917,6 +10190,9 @@
             <a:extLst>
               <a:ext uri="{FF2B5EF4-FFF2-40B4-BE49-F238E27FC236}">
                 <a16:creationId xmlns:a16="http://schemas.microsoft.com/office/drawing/2014/main" id="{BEA1D1E9-EE2D-94F9-5E32-550B1778F785}"/>
+              </a:ext>
+              <a:ext uri="{C183D7F6-B498-43B3-948B-1728B52AA6E4}">
+                <adec:decorative xmlns:adec="http://schemas.microsoft.com/office/drawing/2017/decorative" val="1"/>
               </a:ext>
             </a:extLst>
           </p:cNvPr>
@@ -9046,10 +10322,10 @@
           <a:lstStyle/>
           <a:p>
             <a:r>
-              <a:rPr lang="en-US" dirty="0"/>
+              <a:rPr lang="en-US"/>
               <a:t>Retrieval Stage – Goals and Approach</a:t>
             </a:r>
-            <a:endParaRPr lang="de-DE" dirty="0"/>
+            <a:endParaRPr lang="de-DE"/>
           </a:p>
         </p:txBody>
       </p:sp>
@@ -9075,64 +10351,64 @@
           <a:lstStyle/>
           <a:p>
             <a:r>
-              <a:rPr lang="en-US" dirty="0"/>
+              <a:rPr lang="en-US"/>
               <a:t>Retrieve relevant tweets from authority account timelines</a:t>
             </a:r>
           </a:p>
           <a:p>
             <a:r>
-              <a:rPr lang="en-US" u="sng" dirty="0"/>
+              <a:rPr lang="en-US" u="sng"/>
               <a:t>Lexical</a:t>
             </a:r>
             <a:r>
-              <a:rPr lang="en-US" dirty="0"/>
+              <a:rPr lang="en-US"/>
               <a:t> methods: BM25, TF-IDF</a:t>
             </a:r>
           </a:p>
           <a:p>
             <a:r>
-              <a:rPr lang="en-US" u="sng" dirty="0"/>
+              <a:rPr lang="en-US" u="sng"/>
               <a:t>Semantic</a:t>
             </a:r>
             <a:r>
-              <a:rPr lang="en-US" dirty="0"/>
+              <a:rPr lang="en-US"/>
               <a:t> methods: Embedding Models &amp; Cosine Similarity</a:t>
             </a:r>
           </a:p>
           <a:p>
             <a:r>
-              <a:rPr lang="en-US" dirty="0"/>
+              <a:rPr lang="en-US"/>
               <a:t>Does </a:t>
             </a:r>
             <a:r>
-              <a:rPr lang="en-US" u="sng" dirty="0"/>
+              <a:rPr lang="en-US" u="sng"/>
               <a:t>preprocessing</a:t>
             </a:r>
             <a:r>
-              <a:rPr lang="en-US" dirty="0"/>
+              <a:rPr lang="en-US"/>
               <a:t> or </a:t>
             </a:r>
             <a:r>
-              <a:rPr lang="en-US" u="sng" dirty="0"/>
+              <a:rPr lang="en-US" u="sng"/>
               <a:t>additional info about the authority </a:t>
             </a:r>
             <a:r>
-              <a:rPr lang="en-US" dirty="0"/>
+              <a:rPr lang="en-US"/>
               <a:t>improve Recall?</a:t>
             </a:r>
           </a:p>
           <a:p>
             <a:r>
-              <a:rPr lang="en-US" dirty="0"/>
+              <a:rPr lang="en-US"/>
               <a:t>Balancing retrieval speed and accuracy </a:t>
             </a:r>
             <a:r>
-              <a:rPr lang="en-US" dirty="0">
+              <a:rPr lang="en-US">
                 <a:sym typeface="Wingdings" panose="05000000000000000000" pitchFamily="2" charset="2"/>
               </a:rPr>
               <a:t> Re-Ranking?</a:t>
             </a:r>
-            <a:endParaRPr lang="de-DE" dirty="0"/>
+            <a:endParaRPr lang="de-DE"/>
           </a:p>
         </p:txBody>
       </p:sp>
@@ -9222,16 +10498,16 @@
           <a:lstStyle/>
           <a:p>
             <a:r>
-              <a:rPr lang="en-US" dirty="0"/>
+              <a:rPr lang="en-US"/>
               <a:t>Our Two-Stage Approach</a:t>
             </a:r>
-            <a:endParaRPr lang="de-DE" dirty="0"/>
+            <a:endParaRPr lang="de-DE"/>
           </a:p>
         </p:txBody>
       </p:sp>
       <p:pic>
         <p:nvPicPr>
-          <p:cNvPr id="6" name="Inhaltsplatzhalter 5" descr="Ein Bild, das Text, Screenshot, Diagramm, Schrift enthält.&#10;&#10;Automatisch generierte Beschreibung">
+          <p:cNvPr id="6" name="Inhaltsplatzhalter 5" descr="approach diagram">
             <a:extLst>
               <a:ext uri="{FF2B5EF4-FFF2-40B4-BE49-F238E27FC236}">
                 <a16:creationId xmlns:a16="http://schemas.microsoft.com/office/drawing/2014/main" id="{D57F5F0E-80EF-004C-AA5C-2A040F362508}"/>
@@ -9246,7 +10522,7 @@
           </p:nvPr>
         </p:nvPicPr>
         <p:blipFill>
-          <a:blip r:embed="rId2">
+          <a:blip r:embed="rId3">
             <a:extLst>
               <a:ext uri="{28A0092B-C50C-407E-A947-70E740481C1C}">
                 <a14:useLocalDpi xmlns:a14="http://schemas.microsoft.com/office/drawing/2010/main" val="0"/>
@@ -9270,6 +10546,9 @@
             <a:extLst>
               <a:ext uri="{FF2B5EF4-FFF2-40B4-BE49-F238E27FC236}">
                 <a16:creationId xmlns:a16="http://schemas.microsoft.com/office/drawing/2014/main" id="{4D585186-BC5F-CD4F-3D89-299D677AFDE6}"/>
+              </a:ext>
+              <a:ext uri="{C183D7F6-B498-43B3-948B-1728B52AA6E4}">
+                <adec:decorative xmlns:adec="http://schemas.microsoft.com/office/drawing/2017/decorative" val="1"/>
               </a:ext>
             </a:extLst>
           </p:cNvPr>
@@ -9874,4 +11153,305 @@
     </a:ext>
   </a:extLst>
 </a:theme>
+</file>
+
+<file path=ppt/theme/themeOverride1.xml><?xml version="1.0" encoding="utf-8"?>
+<a:themeOverride xmlns:a="http://schemas.openxmlformats.org/drawingml/2006/main">
+  <a:clrScheme name="Blush 3">
+    <a:dk1>
+      <a:sysClr val="windowText" lastClr="000000"/>
+    </a:dk1>
+    <a:lt1>
+      <a:sysClr val="window" lastClr="FFFFFF"/>
+    </a:lt1>
+    <a:dk2>
+      <a:srgbClr val="B15E4E"/>
+    </a:dk2>
+    <a:lt2>
+      <a:srgbClr val="FFFFFF"/>
+    </a:lt2>
+    <a:accent1>
+      <a:srgbClr val="C5B096"/>
+    </a:accent1>
+    <a:accent2>
+      <a:srgbClr val="ECA855"/>
+    </a:accent2>
+    <a:accent3>
+      <a:srgbClr val="9BBFB0"/>
+    </a:accent3>
+    <a:accent4>
+      <a:srgbClr val="A9AEA7"/>
+    </a:accent4>
+    <a:accent5>
+      <a:srgbClr val="6A787C"/>
+    </a:accent5>
+    <a:accent6>
+      <a:srgbClr val="3B4345"/>
+    </a:accent6>
+    <a:hlink>
+      <a:srgbClr val="ECA855"/>
+    </a:hlink>
+    <a:folHlink>
+      <a:srgbClr val="6A392F"/>
+    </a:folHlink>
+  </a:clrScheme>
+</a:themeOverride>
+</file>
+
+<file path=ppt/theme/themeOverride2.xml><?xml version="1.0" encoding="utf-8"?>
+<a:themeOverride xmlns:a="http://schemas.openxmlformats.org/drawingml/2006/main">
+  <a:clrScheme name="Blush 3">
+    <a:dk1>
+      <a:sysClr val="windowText" lastClr="000000"/>
+    </a:dk1>
+    <a:lt1>
+      <a:sysClr val="window" lastClr="FFFFFF"/>
+    </a:lt1>
+    <a:dk2>
+      <a:srgbClr val="B15E4E"/>
+    </a:dk2>
+    <a:lt2>
+      <a:srgbClr val="FFFFFF"/>
+    </a:lt2>
+    <a:accent1>
+      <a:srgbClr val="C5B096"/>
+    </a:accent1>
+    <a:accent2>
+      <a:srgbClr val="ECA855"/>
+    </a:accent2>
+    <a:accent3>
+      <a:srgbClr val="9BBFB0"/>
+    </a:accent3>
+    <a:accent4>
+      <a:srgbClr val="A9AEA7"/>
+    </a:accent4>
+    <a:accent5>
+      <a:srgbClr val="6A787C"/>
+    </a:accent5>
+    <a:accent6>
+      <a:srgbClr val="3B4345"/>
+    </a:accent6>
+    <a:hlink>
+      <a:srgbClr val="ECA855"/>
+    </a:hlink>
+    <a:folHlink>
+      <a:srgbClr val="6A392F"/>
+    </a:folHlink>
+  </a:clrScheme>
+</a:themeOverride>
+</file>
+
+<file path=customXml/item1.xml><?xml version="1.0" encoding="utf-8"?>
+<p:properties xmlns:p="http://schemas.microsoft.com/office/2006/metadata/properties" xmlns:xsi="http://www.w3.org/2001/XMLSchema-instance" xmlns:pc="http://schemas.microsoft.com/office/infopath/2007/PartnerControls">
+  <documentManagement>
+    <_activity xmlns="7f551316-0840-4564-a5d5-03a2f27fdf00" xsi:nil="true"/>
+  </documentManagement>
+</p:properties>
+</file>
+
+<file path=customXml/item2.xml><?xml version="1.0" encoding="utf-8"?>
+<ct:contentTypeSchema xmlns:ct="http://schemas.microsoft.com/office/2006/metadata/contentType" xmlns:ma="http://schemas.microsoft.com/office/2006/metadata/properties/metaAttributes" ct:_="" ma:_="" ma:contentTypeName="Dokument" ma:contentTypeID="0x0101003264814F2E3F91458EEE949950F49A2D" ma:contentTypeVersion="6" ma:contentTypeDescription="Ein neues Dokument erstellen." ma:contentTypeScope="" ma:versionID="2cf83ff755e1c8bdf27aa2f604dbc099">
+  <xsd:schema xmlns:xsd="http://www.w3.org/2001/XMLSchema" xmlns:xs="http://www.w3.org/2001/XMLSchema" xmlns:p="http://schemas.microsoft.com/office/2006/metadata/properties" xmlns:ns3="7f551316-0840-4564-a5d5-03a2f27fdf00" targetNamespace="http://schemas.microsoft.com/office/2006/metadata/properties" ma:root="true" ma:fieldsID="c97d1d9a559046f44f0ba8dfc51009a2" ns3:_="">
+    <xsd:import namespace="7f551316-0840-4564-a5d5-03a2f27fdf00"/>
+    <xsd:element name="properties">
+      <xsd:complexType>
+        <xsd:sequence>
+          <xsd:element name="documentManagement">
+            <xsd:complexType>
+              <xsd:all>
+                <xsd:element ref="ns3:MediaServiceMetadata" minOccurs="0"/>
+                <xsd:element ref="ns3:MediaServiceFastMetadata" minOccurs="0"/>
+                <xsd:element ref="ns3:MediaServiceObjectDetectorVersions" minOccurs="0"/>
+                <xsd:element ref="ns3:_activity" minOccurs="0"/>
+                <xsd:element ref="ns3:MediaServiceSearchProperties" minOccurs="0"/>
+                <xsd:element ref="ns3:MediaServiceDateTaken" minOccurs="0"/>
+              </xsd:all>
+            </xsd:complexType>
+          </xsd:element>
+        </xsd:sequence>
+      </xsd:complexType>
+    </xsd:element>
+  </xsd:schema>
+  <xsd:schema xmlns:xsd="http://www.w3.org/2001/XMLSchema" xmlns:xs="http://www.w3.org/2001/XMLSchema" xmlns:dms="http://schemas.microsoft.com/office/2006/documentManagement/types" xmlns:pc="http://schemas.microsoft.com/office/infopath/2007/PartnerControls" targetNamespace="7f551316-0840-4564-a5d5-03a2f27fdf00" elementFormDefault="qualified">
+    <xsd:import namespace="http://schemas.microsoft.com/office/2006/documentManagement/types"/>
+    <xsd:import namespace="http://schemas.microsoft.com/office/infopath/2007/PartnerControls"/>
+    <xsd:element name="MediaServiceMetadata" ma:index="8" nillable="true" ma:displayName="MediaServiceMetadata" ma:hidden="true" ma:internalName="MediaServiceMetadata" ma:readOnly="true">
+      <xsd:simpleType>
+        <xsd:restriction base="dms:Note"/>
+      </xsd:simpleType>
+    </xsd:element>
+    <xsd:element name="MediaServiceFastMetadata" ma:index="9" nillable="true" ma:displayName="MediaServiceFastMetadata" ma:hidden="true" ma:internalName="MediaServiceFastMetadata" ma:readOnly="true">
+      <xsd:simpleType>
+        <xsd:restriction base="dms:Note"/>
+      </xsd:simpleType>
+    </xsd:element>
+    <xsd:element name="MediaServiceObjectDetectorVersions" ma:index="10" nillable="true" ma:displayName="MediaServiceObjectDetectorVersions" ma:hidden="true" ma:indexed="true" ma:internalName="MediaServiceObjectDetectorVersions" ma:readOnly="true">
+      <xsd:simpleType>
+        <xsd:restriction base="dms:Text"/>
+      </xsd:simpleType>
+    </xsd:element>
+    <xsd:element name="_activity" ma:index="11" nillable="true" ma:displayName="_activity" ma:hidden="true" ma:internalName="_activity">
+      <xsd:simpleType>
+        <xsd:restriction base="dms:Note"/>
+      </xsd:simpleType>
+    </xsd:element>
+    <xsd:element name="MediaServiceSearchProperties" ma:index="12" nillable="true" ma:displayName="MediaServiceSearchProperties" ma:hidden="true" ma:internalName="MediaServiceSearchProperties" ma:readOnly="true">
+      <xsd:simpleType>
+        <xsd:restriction base="dms:Note"/>
+      </xsd:simpleType>
+    </xsd:element>
+    <xsd:element name="MediaServiceDateTaken" ma:index="13" nillable="true" ma:displayName="MediaServiceDateTaken" ma:hidden="true" ma:indexed="true" ma:internalName="MediaServiceDateTaken" ma:readOnly="true">
+      <xsd:simpleType>
+        <xsd:restriction base="dms:Text"/>
+      </xsd:simpleType>
+    </xsd:element>
+  </xsd:schema>
+  <xsd:schema xmlns="http://schemas.openxmlformats.org/package/2006/metadata/core-properties" xmlns:xsd="http://www.w3.org/2001/XMLSchema" xmlns:xsi="http://www.w3.org/2001/XMLSchema-instance" xmlns:dc="http://purl.org/dc/elements/1.1/" xmlns:dcterms="http://purl.org/dc/terms/" xmlns:odoc="http://schemas.microsoft.com/internal/obd" targetNamespace="http://schemas.openxmlformats.org/package/2006/metadata/core-properties" elementFormDefault="qualified" attributeFormDefault="unqualified" blockDefault="#all">
+    <xsd:import namespace="http://purl.org/dc/elements/1.1/" schemaLocation="http://dublincore.org/schemas/xmls/qdc/2003/04/02/dc.xsd"/>
+    <xsd:import namespace="http://purl.org/dc/terms/" schemaLocation="http://dublincore.org/schemas/xmls/qdc/2003/04/02/dcterms.xsd"/>
+    <xsd:element name="coreProperties" type="CT_coreProperties"/>
+    <xsd:complexType name="CT_coreProperties">
+      <xsd:all>
+        <xsd:element ref="dc:creator" minOccurs="0" maxOccurs="1"/>
+        <xsd:element ref="dcterms:created" minOccurs="0" maxOccurs="1"/>
+        <xsd:element ref="dc:identifier" minOccurs="0" maxOccurs="1"/>
+        <xsd:element name="contentType" minOccurs="0" maxOccurs="1" type="xsd:string" ma:index="0" ma:displayName="Inhaltstyp"/>
+        <xsd:element ref="dc:title" minOccurs="0" maxOccurs="1" ma:index="4" ma:displayName="Titel"/>
+        <xsd:element ref="dc:subject" minOccurs="0" maxOccurs="1"/>
+        <xsd:element ref="dc:description" minOccurs="0" maxOccurs="1"/>
+        <xsd:element name="keywords" minOccurs="0" maxOccurs="1" type="xsd:string"/>
+        <xsd:element ref="dc:language" minOccurs="0" maxOccurs="1"/>
+        <xsd:element name="category" minOccurs="0" maxOccurs="1" type="xsd:string"/>
+        <xsd:element name="version" minOccurs="0" maxOccurs="1" type="xsd:string"/>
+        <xsd:element name="revision" minOccurs="0" maxOccurs="1" type="xsd:string">
+          <xsd:annotation>
+            <xsd:documentation>
+                        This value indicates the number of saves or revisions. The application is responsible for updating this value after each revision.
+                    </xsd:documentation>
+          </xsd:annotation>
+        </xsd:element>
+        <xsd:element name="lastModifiedBy" minOccurs="0" maxOccurs="1" type="xsd:string"/>
+        <xsd:element ref="dcterms:modified" minOccurs="0" maxOccurs="1"/>
+        <xsd:element name="contentStatus" minOccurs="0" maxOccurs="1" type="xsd:string"/>
+      </xsd:all>
+    </xsd:complexType>
+  </xsd:schema>
+  <xs:schema xmlns:pc="http://schemas.microsoft.com/office/infopath/2007/PartnerControls" xmlns:xs="http://www.w3.org/2001/XMLSchema" targetNamespace="http://schemas.microsoft.com/office/infopath/2007/PartnerControls" elementFormDefault="qualified" attributeFormDefault="unqualified">
+    <xs:element name="Person">
+      <xs:complexType>
+        <xs:sequence>
+          <xs:element ref="pc:DisplayName" minOccurs="0"/>
+          <xs:element ref="pc:AccountId" minOccurs="0"/>
+          <xs:element ref="pc:AccountType" minOccurs="0"/>
+        </xs:sequence>
+      </xs:complexType>
+    </xs:element>
+    <xs:element name="DisplayName" type="xs:string"/>
+    <xs:element name="AccountId" type="xs:string"/>
+    <xs:element name="AccountType" type="xs:string"/>
+    <xs:element name="BDCAssociatedEntity">
+      <xs:complexType>
+        <xs:sequence>
+          <xs:element ref="pc:BDCEntity" minOccurs="0" maxOccurs="unbounded"/>
+        </xs:sequence>
+        <xs:attribute ref="pc:EntityNamespace"/>
+        <xs:attribute ref="pc:EntityName"/>
+        <xs:attribute ref="pc:SystemInstanceName"/>
+        <xs:attribute ref="pc:AssociationName"/>
+      </xs:complexType>
+    </xs:element>
+    <xs:attribute name="EntityNamespace" type="xs:string"/>
+    <xs:attribute name="EntityName" type="xs:string"/>
+    <xs:attribute name="SystemInstanceName" type="xs:string"/>
+    <xs:attribute name="AssociationName" type="xs:string"/>
+    <xs:element name="BDCEntity">
+      <xs:complexType>
+        <xs:sequence>
+          <xs:element ref="pc:EntityDisplayName" minOccurs="0"/>
+          <xs:element ref="pc:EntityInstanceReference" minOccurs="0"/>
+          <xs:element ref="pc:EntityId1" minOccurs="0"/>
+          <xs:element ref="pc:EntityId2" minOccurs="0"/>
+          <xs:element ref="pc:EntityId3" minOccurs="0"/>
+          <xs:element ref="pc:EntityId4" minOccurs="0"/>
+          <xs:element ref="pc:EntityId5" minOccurs="0"/>
+        </xs:sequence>
+      </xs:complexType>
+    </xs:element>
+    <xs:element name="EntityDisplayName" type="xs:string"/>
+    <xs:element name="EntityInstanceReference" type="xs:string"/>
+    <xs:element name="EntityId1" type="xs:string"/>
+    <xs:element name="EntityId2" type="xs:string"/>
+    <xs:element name="EntityId3" type="xs:string"/>
+    <xs:element name="EntityId4" type="xs:string"/>
+    <xs:element name="EntityId5" type="xs:string"/>
+    <xs:element name="Terms">
+      <xs:complexType>
+        <xs:sequence>
+          <xs:element ref="pc:TermInfo" minOccurs="0" maxOccurs="unbounded"/>
+        </xs:sequence>
+      </xs:complexType>
+    </xs:element>
+    <xs:element name="TermInfo">
+      <xs:complexType>
+        <xs:sequence>
+          <xs:element ref="pc:TermName" minOccurs="0"/>
+          <xs:element ref="pc:TermId" minOccurs="0"/>
+        </xs:sequence>
+      </xs:complexType>
+    </xs:element>
+    <xs:element name="TermName" type="xs:string"/>
+    <xs:element name="TermId" type="xs:string"/>
+  </xs:schema>
+</ct:contentTypeSchema>
+</file>
+
+<file path=customXml/item3.xml><?xml version="1.0" encoding="utf-8"?>
+<?mso-contentType ?>
+<FormTemplates xmlns="http://schemas.microsoft.com/sharepoint/v3/contenttype/forms">
+  <Display>DocumentLibraryForm</Display>
+  <Edit>DocumentLibraryForm</Edit>
+  <New>DocumentLibraryForm</New>
+</FormTemplates>
+</file>
+
+<file path=customXml/itemProps1.xml><?xml version="1.0" encoding="utf-8"?>
+<ds:datastoreItem xmlns:ds="http://schemas.openxmlformats.org/officeDocument/2006/customXml" ds:itemID="{E888F60B-74CA-4288-9DD7-77C0D96BE640}">
+  <ds:schemaRefs>
+    <ds:schemaRef ds:uri="http://purl.org/dc/elements/1.1/"/>
+    <ds:schemaRef ds:uri="http://purl.org/dc/terms/"/>
+    <ds:schemaRef ds:uri="http://schemas.microsoft.com/office/2006/metadata/properties"/>
+    <ds:schemaRef ds:uri="http://purl.org/dc/dcmitype/"/>
+    <ds:schemaRef ds:uri="http://schemas.microsoft.com/office/infopath/2007/PartnerControls"/>
+    <ds:schemaRef ds:uri="http://schemas.microsoft.com/office/2006/documentManagement/types"/>
+    <ds:schemaRef ds:uri="7f551316-0840-4564-a5d5-03a2f27fdf00"/>
+    <ds:schemaRef ds:uri="http://schemas.openxmlformats.org/package/2006/metadata/core-properties"/>
+    <ds:schemaRef ds:uri="http://www.w3.org/XML/1998/namespace"/>
+  </ds:schemaRefs>
+</ds:datastoreItem>
+</file>
+
+<file path=customXml/itemProps2.xml><?xml version="1.0" encoding="utf-8"?>
+<ds:datastoreItem xmlns:ds="http://schemas.openxmlformats.org/officeDocument/2006/customXml" ds:itemID="{8746BA5B-0332-4587-91E1-C73169AEA2C3}">
+  <ds:schemaRefs>
+    <ds:schemaRef ds:uri="7f551316-0840-4564-a5d5-03a2f27fdf00"/>
+    <ds:schemaRef ds:uri="http://purl.org/dc/elements/1.1/"/>
+    <ds:schemaRef ds:uri="http://purl.org/dc/terms/"/>
+    <ds:schemaRef ds:uri="http://schemas.microsoft.com/internal/obd"/>
+    <ds:schemaRef ds:uri="http://schemas.microsoft.com/office/2006/documentManagement/types"/>
+    <ds:schemaRef ds:uri="http://schemas.microsoft.com/office/2006/metadata/contentType"/>
+    <ds:schemaRef ds:uri="http://schemas.microsoft.com/office/2006/metadata/properties"/>
+    <ds:schemaRef ds:uri="http://schemas.microsoft.com/office/2006/metadata/properties/metaAttributes"/>
+    <ds:schemaRef ds:uri="http://schemas.microsoft.com/office/infopath/2007/PartnerControls"/>
+    <ds:schemaRef ds:uri="http://schemas.openxmlformats.org/package/2006/metadata/core-properties"/>
+    <ds:schemaRef ds:uri="http://www.w3.org/2001/XMLSchema"/>
+  </ds:schemaRefs>
+</ds:datastoreItem>
+</file>
+
+<file path=customXml/itemProps3.xml><?xml version="1.0" encoding="utf-8"?>
+<ds:datastoreItem xmlns:ds="http://schemas.openxmlformats.org/officeDocument/2006/customXml" ds:itemID="{90E990E1-468D-4C2F-9D61-648FA526F443}">
+  <ds:schemaRefs>
+    <ds:schemaRef ds:uri="http://schemas.microsoft.com/sharepoint/v3/contenttype/forms"/>
+  </ds:schemaRefs>
+</ds:datastoreItem>
 </file>
</xml_diff>